<commit_message>
docs(presentation): perspectives - verger, planification, carnet de suivi sanitaire
Co-Authored-By: Claude Opus 5.5 <noreply@anthropic.com>
Claude-Session: https://claude.ai/code/session_01N6gjkuzRQ2MG332QwTLsQa
</commit_message>
<xml_diff>
--- a/presentation/Presentation_outil_maraichage.pptx
+++ b/presentation/Presentation_outil_maraichage.pptx
@@ -1247,7 +1247,7 @@
           <a:p>
             <a:r>
               <a:rPr lang="en-US" dirty="0"/>
-              <a:t>Mettre en avant l'extension pépinière (fruitiers insolites, vivaces), cohérente avec l'activité propre. Préciser le calendrier envisagé.</a:t>
+              <a:t>Le carnet de suivi n'est pas encore rattaché à une parcelle : il s'appuie sur les cultures sélectionnées dans l'app. Croisé avec l'historique des alertes, il permettra de vérifier dans le temps si les alertes justifiaient bien une intervention préventive. Préciser le calendrier envisagé.</a:t>
             </a:r>
             <a:endParaRPr lang="en-US" dirty="0"/>
           </a:p>
@@ -3364,7 +3364,7 @@
                 <a:ea typeface="Cambria" pitchFamily="34" charset="-122"/>
                 <a:cs typeface="Cambria" pitchFamily="34" charset="-120"/>
               </a:rPr>
-              <a:t>Fruitiers insolites &amp; légumes vivaces</a:t>
+              <a:t>Fruitiers / verger</a:t>
             </a:r>
             <a:endParaRPr lang="en-US" sz="1800" dirty="0"/>
           </a:p>
@@ -3379,7 +3379,7 @@
         <p:spPr>
           <a:xfrm>
             <a:off x="640080" y="3977640"/>
-            <a:ext cx="2560320" cy="731520"/>
+            <a:ext cx="2560320" cy="1280160"/>
           </a:xfrm>
           <a:prstGeom prst="rect">
             <a:avLst/>
@@ -3403,7 +3403,7 @@
                 <a:ea typeface="Calibri" pitchFamily="34" charset="-122"/>
                 <a:cs typeface="Calibri" pitchFamily="34" charset="-120"/>
               </a:rPr>
-              <a:t>Étendre les fiches à la pépinière</a:t>
+              <a:t>Étendre les fiches et les alertes aux arbres fruitiers</a:t>
             </a:r>
             <a:endParaRPr lang="en-US" sz="1400" dirty="0"/>
           </a:p>
@@ -3506,7 +3506,7 @@
         <p:spPr>
           <a:xfrm>
             <a:off x="3429000" y="3977640"/>
-            <a:ext cx="2560320" cy="731520"/>
+            <a:ext cx="2560320" cy="1280160"/>
           </a:xfrm>
           <a:prstGeom prst="rect">
             <a:avLst/>
@@ -3530,7 +3530,7 @@
                 <a:ea typeface="Calibri" pitchFamily="34" charset="-122"/>
                 <a:cs typeface="Calibri" pitchFamily="34" charset="-120"/>
               </a:rPr>
-              <a:t>Selon saison et zone climatique</a:t>
+              <a:t>Selon saison et zone climatique, avec planification des cultures</a:t>
             </a:r>
             <a:endParaRPr lang="en-US" sz="1400" dirty="0"/>
           </a:p>
@@ -3618,7 +3618,7 @@
                 <a:ea typeface="Cambria" pitchFamily="34" charset="-122"/>
                 <a:cs typeface="Cambria" pitchFamily="34" charset="-120"/>
               </a:rPr>
-              <a:t>Carnet d'observations</a:t>
+              <a:t>Carnet de suivi sanitaire</a:t>
             </a:r>
             <a:endParaRPr lang="en-US" sz="1800" dirty="0"/>
           </a:p>
@@ -3633,7 +3633,7 @@
         <p:spPr>
           <a:xfrm>
             <a:off x="6217920" y="3977640"/>
-            <a:ext cx="2560320" cy="731520"/>
+            <a:ext cx="2560320" cy="1280160"/>
           </a:xfrm>
           <a:prstGeom prst="rect">
             <a:avLst/>
@@ -3657,7 +3657,7 @@
                 <a:ea typeface="Calibri" pitchFamily="34" charset="-122"/>
                 <a:cs typeface="Calibri" pitchFamily="34" charset="-120"/>
               </a:rPr>
-              <a:t>Parcelles, dates, photos de terrain</a:t>
+              <a:t>Pour chaque culture suivie : maladie observée ou non, traitement réalisé (date, produit, notes)</a:t>
             </a:r>
             <a:endParaRPr lang="en-US" sz="1400" dirty="0"/>
           </a:p>
@@ -3760,7 +3760,7 @@
         <p:spPr>
           <a:xfrm>
             <a:off x="9006840" y="3977640"/>
-            <a:ext cx="2560320" cy="731520"/>
+            <a:ext cx="2560320" cy="1280160"/>
           </a:xfrm>
           <a:prstGeom prst="rect">
             <a:avLst/>
@@ -3784,7 +3784,7 @@
                 <a:ea typeface="Calibri" pitchFamily="34" charset="-122"/>
                 <a:cs typeface="Calibri" pitchFamily="34" charset="-120"/>
               </a:rPr>
-              <a:t>Comparaisons inter-saisons</a:t>
+              <a:t>Confronter alertes et observations pour confirmer, saison après saison, l'utilité des interventions préventives</a:t>
             </a:r>
             <a:endParaRPr lang="en-US" sz="1400" dirty="0"/>
           </a:p>

</xml_diff>

<commit_message>
docs(presentation): retirer la diapo « L'outil en chiffres »
Co-Authored-By: Claude Opus 5.5 <noreply@anthropic.com>
Claude-Session: https://claude.ai/code/session_01N6gjkuzRQ2MG332QwTLsQa
</commit_message>
<xml_diff>
--- a/presentation/Presentation_outil_maraichage.pptx
+++ b/presentation/Presentation_outil_maraichage.pptx
@@ -16,10 +16,9 @@
     <p:sldId id="264" r:id="rId10"/>
     <p:sldId id="265" r:id="rId11"/>
     <p:sldId id="266" r:id="rId12"/>
-    <p:sldId id="267" r:id="rId13"/>
   </p:sldIdLst>
   <p:notesMasterIdLst>
-    <p:notesMasterId r:id="rId14"/>
+    <p:notesMasterId r:id="rId13"/>
   </p:notesMasterIdLst>
   <p:sldSz cx="12192000" cy="6858000"/>
   <p:notesSz cx="6858000" cy="12192000"/>
@@ -1159,7 +1158,7 @@
           <a:p>
             <a:r>
               <a:rPr lang="en-US" dirty="0"/>
-              <a:t>Transparence méthodologique. Piste de validation : confronter les alertes aux observations de terrain sur une saison.</a:t>
+              <a:t>Le carnet de suivi n'est pas encore rattaché à une parcelle : il s'appuie sur les cultures sélectionnées dans l'app. Croisé avec l'historique des alertes, il permettra de vérifier dans le temps si les alertes justifiaient bien une intervention préventive. Préciser le calendrier envisagé.</a:t>
             </a:r>
             <a:endParaRPr lang="en-US" dirty="0"/>
           </a:p>
@@ -1247,7 +1246,7 @@
           <a:p>
             <a:r>
               <a:rPr lang="en-US" dirty="0"/>
-              <a:t>Le carnet de suivi n'est pas encore rattaché à une parcelle : il s'appuie sur les cultures sélectionnées dans l'app. Croisé avec l'historique des alertes, il permettra de vérifier dans le temps si les alertes justifiaient bien une intervention préventive. Préciser le calendrier envisagé.</a:t>
+              <a:t>Questions / démonstration en direct. Préparer un QR code vers l'application.</a:t>
             </a:r>
             <a:endParaRPr lang="en-US" dirty="0"/>
           </a:p>
@@ -1271,94 +1270,6 @@
             <a:fld id="{F7021451-1387-4CA6-816F-3879F97B5CBC}" type="slidenum">
               <a:rPr lang="en-US"/>
               <a:t>11</a:t>
-            </a:fld>
-            <a:endParaRPr lang="en-US"/>
-          </a:p>
-        </p:txBody>
-      </p:sp>
-    </p:spTree>
-    <p:extLst>
-      <p:ext uri="{BB962C8B-B14F-4D97-AF65-F5344CB8AC3E}">
-        <p14:creationId xmlns:p14="http://schemas.microsoft.com/office/powerpoint/2010/main" val="1024086991"/>
-      </p:ext>
-    </p:extLst>
-  </p:cSld>
-  <p:clrMapOvr>
-    <a:masterClrMapping/>
-  </p:clrMapOvr>
-</p:notes>
-</file>
-
-<file path=ppt/notesSlides/notesSlide12.xml><?xml version="1.0" encoding="utf-8"?>
-<p:notes xmlns:a="http://schemas.openxmlformats.org/drawingml/2006/main" xmlns:r="http://schemas.openxmlformats.org/officeDocument/2006/relationships" xmlns:p="http://schemas.openxmlformats.org/presentationml/2006/main">
-  <p:cSld>
-    <p:spTree>
-      <p:nvGrpSpPr>
-        <p:cNvPr id="1" name=""/>
-        <p:cNvGrpSpPr/>
-        <p:nvPr/>
-      </p:nvGrpSpPr>
-      <p:grpSpPr>
-        <a:xfrm>
-          <a:off x="0" y="0"/>
-          <a:ext cx="0" cy="0"/>
-          <a:chOff x="0" y="0"/>
-          <a:chExt cx="0" cy="0"/>
-        </a:xfrm>
-      </p:grpSpPr>
-      <p:sp>
-        <p:nvSpPr>
-          <p:cNvPr id="2" name="Slide Image Placeholder 1"/>
-          <p:cNvSpPr>
-            <a:spLocks noGrp="1" noRot="1" noChangeAspect="1"/>
-          </p:cNvSpPr>
-          <p:nvPr>
-            <p:ph type="sldImg"/>
-          </p:nvPr>
-        </p:nvSpPr>
-        <p:spPr/>
-      </p:sp>
-      <p:sp>
-        <p:nvSpPr>
-          <p:cNvPr id="3" name="Notes Placeholder 2"/>
-          <p:cNvSpPr>
-            <a:spLocks noGrp="1"/>
-          </p:cNvSpPr>
-          <p:nvPr>
-            <p:ph type="body" idx="1"/>
-          </p:nvPr>
-        </p:nvSpPr>
-        <p:spPr/>
-        <p:txBody>
-          <a:bodyPr/>
-          <a:lstStyle/>
-          <a:p>
-            <a:r>
-              <a:rPr lang="en-US" dirty="0"/>
-              <a:t>Questions / démonstration en direct. Préparer un QR code vers l'application.</a:t>
-            </a:r>
-            <a:endParaRPr lang="en-US" dirty="0"/>
-          </a:p>
-        </p:txBody>
-      </p:sp>
-      <p:sp>
-        <p:nvSpPr>
-          <p:cNvPr id="4" name="Slide Number Placeholder 3"/>
-          <p:cNvSpPr>
-            <a:spLocks noGrp="1"/>
-          </p:cNvSpPr>
-          <p:nvPr>
-            <p:ph type="sldNum" sz="quarter" idx="10"/>
-          </p:nvPr>
-        </p:nvSpPr>
-        <p:spPr/>
-        <p:txBody>
-          <a:bodyPr/>
-          <a:lstStyle/>
-          <a:p>
-            <a:fld id="{F7021451-1387-4CA6-816F-3879F97B5CBC}" type="slidenum">
-              <a:rPr lang="en-US"/>
-              <a:t>12</a:t>
             </a:fld>
             <a:endParaRPr lang="en-US"/>
           </a:p>
@@ -1951,7 +1862,7 @@
           <a:p>
             <a:r>
               <a:rPr lang="en-US" dirty="0"/>
-              <a:t>Diapo respiration : laisser les chiffres parler.</a:t>
+              <a:t>Lien possible avec la dimension socio-économique : accessibilité pour les petites fermes, reproductibilité, low-tech.</a:t>
             </a:r>
             <a:endParaRPr lang="en-US" dirty="0"/>
           </a:p>
@@ -2039,7 +1950,7 @@
           <a:p>
             <a:r>
               <a:rPr lang="en-US" dirty="0"/>
-              <a:t>Lien possible avec la dimension socio-économique : accessibilité pour les petites fermes, reproductibilité, low-tech.</a:t>
+              <a:t>Transparence méthodologique. Piste de validation : confronter les alertes aux observations de terrain sur une saison.</a:t>
             </a:r>
             <a:endParaRPr lang="en-US" dirty="0"/>
           </a:p>
@@ -2715,7 +2626,7 @@
                 <a:ea typeface="Cambria" pitchFamily="34" charset="-122"/>
                 <a:cs typeface="Cambria" pitchFamily="34" charset="-120"/>
               </a:rPr>
-              <a:t>Sources </a:t>
+              <a:t>Perspectives </a:t>
             </a:r>
             <a:pPr indent="0" marL="0">
               <a:buNone/>
@@ -2729,7 +2640,7 @@
                 <a:ea typeface="Cambria" pitchFamily="34" charset="-122"/>
                 <a:cs typeface="Cambria" pitchFamily="34" charset="-120"/>
               </a:rPr>
-              <a:t>et limites</a:t>
+              <a:t>d'évolution</a:t>
             </a:r>
             <a:endParaRPr lang="en-US" sz="3600" dirty="0"/>
           </a:p>
@@ -2743,297 +2654,8 @@
         </p:nvSpPr>
         <p:spPr>
           <a:xfrm>
-            <a:off x="640080" y="1463040"/>
-            <a:ext cx="5303520" cy="3657600"/>
-          </a:xfrm>
-          <a:prstGeom prst="roundRect">
-            <a:avLst>
-              <a:gd name="adj" fmla="val 3000"/>
-            </a:avLst>
-          </a:prstGeom>
-          <a:solidFill>
-            <a:srgbClr val="FFFFFF"/>
-          </a:solidFill>
-          <a:ln w="9525">
-            <a:solidFill>
-              <a:srgbClr val="DCD5C3"/>
-            </a:solidFill>
-            <a:prstDash val="solid"/>
-          </a:ln>
-          <a:effectLst>
-            <a:outerShdw sx="100000" sy="100000" kx="0" ky="0" algn="bl" rotWithShape="0" blurRad="101600" dist="25400" dir="5400000">
-              <a:srgbClr val="000000">
-                <a:alpha val="12000"/>
-              </a:srgbClr>
-            </a:outerShdw>
-          </a:effectLst>
-        </p:spPr>
-      </p:sp>
-      <p:sp>
-        <p:nvSpPr>
-          <p:cNvPr id="4" name="Shape 2"/>
-          <p:cNvSpPr/>
-          <p:nvPr/>
-        </p:nvSpPr>
-        <p:spPr>
-          <a:xfrm>
-            <a:off x="914400" y="1737360"/>
-            <a:ext cx="640080" cy="640080"/>
-          </a:xfrm>
-          <a:prstGeom prst="ellipse">
-            <a:avLst/>
-          </a:prstGeom>
-          <a:solidFill>
-            <a:srgbClr val="4A5E2E"/>
-          </a:solidFill>
-          <a:ln w="12700">
-            <a:solidFill>
-              <a:srgbClr val="4A5E2E"/>
-            </a:solidFill>
-            <a:prstDash val="solid"/>
-          </a:ln>
-        </p:spPr>
-      </p:sp>
-      <p:pic>
-        <p:nvPicPr>
-          <p:cNvPr id="5" name="Image 0" descr="preencoded.png">    </p:cNvPr>
-          <p:cNvPicPr>
-            <a:picLocks noChangeAspect="1"/>
-          </p:cNvPicPr>
-          <p:nvPr/>
-        </p:nvPicPr>
-        <p:blipFill>
-          <a:blip r:embed="rId1"/>
-          <a:stretch>
-            <a:fillRect/>
-          </a:stretch>
-        </p:blipFill>
-        <p:spPr>
-          <a:xfrm>
-            <a:off x="1074420" y="1897380"/>
-            <a:ext cx="320040" cy="320040"/>
-          </a:xfrm>
-          <a:prstGeom prst="rect">
-            <a:avLst/>
-          </a:prstGeom>
-        </p:spPr>
-      </p:pic>
-      <p:sp>
-        <p:nvSpPr>
-          <p:cNvPr id="6" name="Text 3"/>
-          <p:cNvSpPr txBox="1"/>
-          <p:nvPr/>
-        </p:nvSpPr>
-        <p:spPr>
-          <a:xfrm>
-            <a:off x="1737360" y="1783080"/>
-            <a:ext cx="4023360" cy="548640"/>
-          </a:xfrm>
-          <a:prstGeom prst="rect">
-            <a:avLst/>
-          </a:prstGeom>
-          <a:noFill/>
-          <a:ln/>
-        </p:spPr>
-        <p:txBody>
-          <a:bodyPr wrap="square" lIns="0" tIns="0" rIns="0" bIns="0" rtlCol="0" anchor="ctr"/>
-          <a:lstStyle/>
-          <a:p>
-            <a:pPr indent="0" marL="0">
-              <a:buNone/>
-            </a:pPr>
-            <a:r>
-              <a:rPr lang="en-US" sz="2000" b="1" dirty="0">
-                <a:solidFill>
-                  <a:srgbClr val="22261C"/>
-                </a:solidFill>
-                <a:latin typeface="Cambria" pitchFamily="34" charset="0"/>
-                <a:ea typeface="Cambria" pitchFamily="34" charset="-122"/>
-                <a:cs typeface="Cambria" pitchFamily="34" charset="-120"/>
-              </a:rPr>
-              <a:t>Références mobilisées</a:t>
-            </a:r>
-            <a:endParaRPr lang="en-US" sz="2000" dirty="0"/>
-          </a:p>
-        </p:txBody>
-      </p:sp>
-      <p:sp>
-        <p:nvSpPr>
-          <p:cNvPr id="7" name="Text 4"/>
-          <p:cNvSpPr txBox="1"/>
-          <p:nvPr/>
-        </p:nvSpPr>
-        <p:spPr>
-          <a:xfrm>
-            <a:off x="914400" y="2560320"/>
-            <a:ext cx="4754880" cy="3200400"/>
-          </a:xfrm>
-          <a:prstGeom prst="rect">
-            <a:avLst/>
-          </a:prstGeom>
-          <a:noFill/>
-          <a:ln/>
-        </p:spPr>
-        <p:txBody>
-          <a:bodyPr wrap="square" lIns="0" tIns="0" rIns="0" bIns="0" rtlCol="0" anchor="t"/>
-          <a:lstStyle/>
-          <a:p>
-            <a:pPr indent="0" marL="0">
-              <a:spcAft>
-                <a:spcPts val="1000"/>
-              </a:spcAft>
-              <a:buNone/>
-            </a:pPr>
-            <a:r>
-              <a:rPr lang="en-US" sz="1500" b="1" dirty="0">
-                <a:solidFill>
-                  <a:srgbClr val="22261C"/>
-                </a:solidFill>
-                <a:latin typeface="Calibri" pitchFamily="34" charset="0"/>
-                <a:ea typeface="Calibri" pitchFamily="34" charset="-122"/>
-                <a:cs typeface="Calibri" pitchFamily="34" charset="-120"/>
-              </a:rPr>
-              <a:t>Maraîchage : </a:t>
-            </a:r>
-            <a:pPr indent="0" marL="0">
-              <a:spcAft>
-                <a:spcPts val="1000"/>
-              </a:spcAft>
-              <a:buNone/>
-            </a:pPr>
-            <a:r>
-              <a:rPr lang="en-US" sz="1500" dirty="0">
-                <a:solidFill>
-                  <a:srgbClr val="22261C"/>
-                </a:solidFill>
-                <a:latin typeface="Calibri" pitchFamily="34" charset="0"/>
-                <a:ea typeface="Calibri" pitchFamily="34" charset="-122"/>
-                <a:cs typeface="Calibri" pitchFamily="34" charset="-120"/>
-              </a:rPr>
-              <a:t>AgroBio Bretagne, GRAB, GAB, FNAB, Agrosemens</a:t>
-            </a:r>
-            <a:endParaRPr lang="en-US" sz="1500" dirty="0"/>
-          </a:p>
-          <a:p>
-            <a:pPr indent="0" marL="0">
-              <a:spcAft>
-                <a:spcPts val="1000"/>
-              </a:spcAft>
-              <a:buNone/>
-            </a:pPr>
-            <a:r>
-              <a:rPr lang="en-US" sz="1500" b="1" dirty="0">
-                <a:solidFill>
-                  <a:srgbClr val="22261C"/>
-                </a:solidFill>
-                <a:latin typeface="Calibri" pitchFamily="34" charset="0"/>
-                <a:ea typeface="Calibri" pitchFamily="34" charset="-122"/>
-                <a:cs typeface="Calibri" pitchFamily="34" charset="-120"/>
-              </a:rPr>
-              <a:t>Maladies &amp; climat : </a:t>
-            </a:r>
-            <a:pPr indent="0" marL="0">
-              <a:spcAft>
-                <a:spcPts val="1000"/>
-              </a:spcAft>
-              <a:buNone/>
-            </a:pPr>
-            <a:r>
-              <a:rPr lang="en-US" sz="1500" dirty="0">
-                <a:solidFill>
-                  <a:srgbClr val="22261C"/>
-                </a:solidFill>
-                <a:latin typeface="Calibri" pitchFamily="34" charset="0"/>
-                <a:ea typeface="Calibri" pitchFamily="34" charset="-122"/>
-                <a:cs typeface="Calibri" pitchFamily="34" charset="-120"/>
-              </a:rPr>
-              <a:t>INRAE Ephytia, ITAB, ARVALIS, MAB16 2024, GECO Ecophytopic</a:t>
-            </a:r>
-            <a:endParaRPr lang="en-US" sz="1500" dirty="0"/>
-          </a:p>
-          <a:p>
-            <a:pPr indent="0" marL="0">
-              <a:spcAft>
-                <a:spcPts val="1000"/>
-              </a:spcAft>
-              <a:buNone/>
-            </a:pPr>
-            <a:r>
-              <a:rPr lang="en-US" sz="1500" b="1" dirty="0">
-                <a:solidFill>
-                  <a:srgbClr val="22261C"/>
-                </a:solidFill>
-                <a:latin typeface="Calibri" pitchFamily="34" charset="0"/>
-                <a:ea typeface="Calibri" pitchFamily="34" charset="-122"/>
-                <a:cs typeface="Calibri" pitchFamily="34" charset="-120"/>
-              </a:rPr>
-              <a:t>Météo : </a:t>
-            </a:r>
-            <a:pPr indent="0" marL="0">
-              <a:spcAft>
-                <a:spcPts val="1000"/>
-              </a:spcAft>
-              <a:buNone/>
-            </a:pPr>
-            <a:r>
-              <a:rPr lang="en-US" sz="1500" dirty="0">
-                <a:solidFill>
-                  <a:srgbClr val="22261C"/>
-                </a:solidFill>
-                <a:latin typeface="Calibri" pitchFamily="34" charset="0"/>
-                <a:ea typeface="Calibri" pitchFamily="34" charset="-122"/>
-                <a:cs typeface="Calibri" pitchFamily="34" charset="-120"/>
-              </a:rPr>
-              <a:t>Open-Meteo (gratuit, sans clé API)</a:t>
-            </a:r>
-            <a:endParaRPr lang="en-US" sz="1500" dirty="0"/>
-          </a:p>
-        </p:txBody>
-      </p:sp>
-      <p:sp>
-        <p:nvSpPr>
-          <p:cNvPr id="8" name="Shape 5"/>
-          <p:cNvSpPr/>
-          <p:nvPr/>
-        </p:nvSpPr>
-        <p:spPr>
-          <a:xfrm>
-            <a:off x="6263640" y="1463040"/>
-            <a:ext cx="5303520" cy="3657600"/>
-          </a:xfrm>
-          <a:prstGeom prst="roundRect">
-            <a:avLst>
-              <a:gd name="adj" fmla="val 3000"/>
-            </a:avLst>
-          </a:prstGeom>
-          <a:solidFill>
-            <a:srgbClr val="FFFFFF"/>
-          </a:solidFill>
-          <a:ln w="9525">
-            <a:solidFill>
-              <a:srgbClr val="DCD5C3"/>
-            </a:solidFill>
-            <a:prstDash val="solid"/>
-          </a:ln>
-          <a:effectLst>
-            <a:outerShdw sx="100000" sy="100000" kx="0" ky="0" algn="bl" rotWithShape="0" blurRad="101600" dist="25400" dir="5400000">
-              <a:srgbClr val="000000">
-                <a:alpha val="12000"/>
-              </a:srgbClr>
-            </a:outerShdw>
-          </a:effectLst>
-        </p:spPr>
-      </p:sp>
-      <p:sp>
-        <p:nvSpPr>
-          <p:cNvPr id="9" name="Shape 6"/>
-          <p:cNvSpPr/>
-          <p:nvPr/>
-        </p:nvSpPr>
-        <p:spPr>
-          <a:xfrm>
-            <a:off x="6537960" y="1737360"/>
-            <a:ext cx="640080" cy="640080"/>
+            <a:off x="1417320" y="1828800"/>
+            <a:ext cx="1005840" cy="1005840"/>
           </a:xfrm>
           <a:prstGeom prst="ellipse">
             <a:avLst/>
@@ -3051,7 +2673,134 @@
       </p:sp>
       <p:pic>
         <p:nvPicPr>
-          <p:cNvPr id="10" name="Image 1" descr="preencoded.png">    </p:cNvPr>
+          <p:cNvPr id="4" name="Image 0" descr="preencoded.png">    </p:cNvPr>
+          <p:cNvPicPr>
+            <a:picLocks noChangeAspect="1"/>
+          </p:cNvPicPr>
+          <p:nvPr/>
+        </p:nvPicPr>
+        <p:blipFill>
+          <a:blip r:embed="rId1"/>
+          <a:stretch>
+            <a:fillRect/>
+          </a:stretch>
+        </p:blipFill>
+        <p:spPr>
+          <a:xfrm>
+            <a:off x="1668780" y="2080260"/>
+            <a:ext cx="502920" cy="502920"/>
+          </a:xfrm>
+          <a:prstGeom prst="rect">
+            <a:avLst/>
+          </a:prstGeom>
+        </p:spPr>
+      </p:pic>
+      <p:sp>
+        <p:nvSpPr>
+          <p:cNvPr id="5" name="Text 2"/>
+          <p:cNvSpPr txBox="1"/>
+          <p:nvPr/>
+        </p:nvSpPr>
+        <p:spPr>
+          <a:xfrm>
+            <a:off x="640080" y="3108960"/>
+            <a:ext cx="2560320" cy="822960"/>
+          </a:xfrm>
+          <a:prstGeom prst="rect">
+            <a:avLst/>
+          </a:prstGeom>
+          <a:noFill/>
+          <a:ln/>
+        </p:spPr>
+        <p:txBody>
+          <a:bodyPr wrap="square" lIns="0" tIns="0" rIns="0" bIns="0" rtlCol="0" anchor="t"/>
+          <a:lstStyle/>
+          <a:p>
+            <a:pPr algn="ctr" indent="0" marL="0">
+              <a:buNone/>
+            </a:pPr>
+            <a:r>
+              <a:rPr lang="en-US" sz="1800" b="1" dirty="0">
+                <a:solidFill>
+                  <a:srgbClr val="22261C"/>
+                </a:solidFill>
+                <a:latin typeface="Cambria" pitchFamily="34" charset="0"/>
+                <a:ea typeface="Cambria" pitchFamily="34" charset="-122"/>
+                <a:cs typeface="Cambria" pitchFamily="34" charset="-120"/>
+              </a:rPr>
+              <a:t>Fruitiers / verger</a:t>
+            </a:r>
+            <a:endParaRPr lang="en-US" sz="1800" dirty="0"/>
+          </a:p>
+        </p:txBody>
+      </p:sp>
+      <p:sp>
+        <p:nvSpPr>
+          <p:cNvPr id="6" name="Text 3"/>
+          <p:cNvSpPr txBox="1"/>
+          <p:nvPr/>
+        </p:nvSpPr>
+        <p:spPr>
+          <a:xfrm>
+            <a:off x="640080" y="3977640"/>
+            <a:ext cx="2560320" cy="1280160"/>
+          </a:xfrm>
+          <a:prstGeom prst="rect">
+            <a:avLst/>
+          </a:prstGeom>
+          <a:noFill/>
+          <a:ln/>
+        </p:spPr>
+        <p:txBody>
+          <a:bodyPr wrap="square" lIns="0" tIns="0" rIns="0" bIns="0" rtlCol="0" anchor="t"/>
+          <a:lstStyle/>
+          <a:p>
+            <a:pPr algn="ctr" indent="0" marL="0">
+              <a:buNone/>
+            </a:pPr>
+            <a:r>
+              <a:rPr lang="en-US" sz="1400" dirty="0">
+                <a:solidFill>
+                  <a:srgbClr val="6B6A5C"/>
+                </a:solidFill>
+                <a:latin typeface="Calibri" pitchFamily="34" charset="0"/>
+                <a:ea typeface="Calibri" pitchFamily="34" charset="-122"/>
+                <a:cs typeface="Calibri" pitchFamily="34" charset="-120"/>
+              </a:rPr>
+              <a:t>Étendre les fiches et les alertes aux arbres fruitiers</a:t>
+            </a:r>
+            <a:endParaRPr lang="en-US" sz="1400" dirty="0"/>
+          </a:p>
+        </p:txBody>
+      </p:sp>
+      <p:sp>
+        <p:nvSpPr>
+          <p:cNvPr id="7" name="Shape 4"/>
+          <p:cNvSpPr/>
+          <p:nvPr/>
+        </p:nvSpPr>
+        <p:spPr>
+          <a:xfrm>
+            <a:off x="4206240" y="1828800"/>
+            <a:ext cx="1005840" cy="1005840"/>
+          </a:xfrm>
+          <a:prstGeom prst="ellipse">
+            <a:avLst/>
+          </a:prstGeom>
+          <a:solidFill>
+            <a:srgbClr val="2B3A1F"/>
+          </a:solidFill>
+          <a:ln w="12700">
+            <a:solidFill>
+              <a:srgbClr val="2B3A1F"/>
+            </a:solidFill>
+            <a:prstDash val="solid"/>
+          </a:ln>
+        </p:spPr>
+      </p:sp>
+      <p:pic>
+        <p:nvPicPr>
+          <p:cNvPr id="8" name="Image 1" descr="preencoded.png">    </p:cNvPr>
           <p:cNvPicPr>
             <a:picLocks noChangeAspect="1"/>
           </p:cNvPicPr>
@@ -3065,8 +2814,8 @@
         </p:blipFill>
         <p:spPr>
           <a:xfrm>
-            <a:off x="6697980" y="1897380"/>
-            <a:ext cx="320040" cy="320040"/>
+            <a:off x="4457700" y="2080260"/>
+            <a:ext cx="502920" cy="502920"/>
           </a:xfrm>
           <a:prstGeom prst="rect">
             <a:avLst/>
@@ -3075,14 +2824,14 @@
       </p:pic>
       <p:sp>
         <p:nvSpPr>
-          <p:cNvPr id="11" name="Text 7"/>
+          <p:cNvPr id="9" name="Text 5"/>
           <p:cNvSpPr txBox="1"/>
           <p:nvPr/>
         </p:nvSpPr>
         <p:spPr>
           <a:xfrm>
-            <a:off x="7360920" y="1783080"/>
-            <a:ext cx="4023360" cy="548640"/>
+            <a:off x="3429000" y="3108960"/>
+            <a:ext cx="2560320" cy="822960"/>
           </a:xfrm>
           <a:prstGeom prst="rect">
             <a:avLst/>
@@ -3091,14 +2840,14 @@
           <a:ln/>
         </p:spPr>
         <p:txBody>
-          <a:bodyPr wrap="square" lIns="0" tIns="0" rIns="0" bIns="0" rtlCol="0" anchor="ctr"/>
-          <a:lstStyle/>
-          <a:p>
-            <a:pPr indent="0" marL="0">
-              <a:buNone/>
-            </a:pPr>
-            <a:r>
-              <a:rPr lang="en-US" sz="2000" b="1" dirty="0">
+          <a:bodyPr wrap="square" lIns="0" tIns="0" rIns="0" bIns="0" rtlCol="0" anchor="t"/>
+          <a:lstStyle/>
+          <a:p>
+            <a:pPr algn="ctr" indent="0" marL="0">
+              <a:buNone/>
+            </a:pPr>
+            <a:r>
+              <a:rPr lang="en-US" sz="1800" b="1" dirty="0">
                 <a:solidFill>
                   <a:srgbClr val="22261C"/>
                 </a:solidFill>
@@ -3106,22 +2855,22 @@
                 <a:ea typeface="Cambria" pitchFamily="34" charset="-122"/>
                 <a:cs typeface="Cambria" pitchFamily="34" charset="-120"/>
               </a:rPr>
-              <a:t>Limites connues</a:t>
-            </a:r>
-            <a:endParaRPr lang="en-US" sz="2000" dirty="0"/>
-          </a:p>
-        </p:txBody>
-      </p:sp>
-      <p:sp>
-        <p:nvSpPr>
-          <p:cNvPr id="12" name="Text 8"/>
+              <a:t>Calendrier de semis local</a:t>
+            </a:r>
+            <a:endParaRPr lang="en-US" sz="1800" dirty="0"/>
+          </a:p>
+        </p:txBody>
+      </p:sp>
+      <p:sp>
+        <p:nvSpPr>
+          <p:cNvPr id="10" name="Text 6"/>
           <p:cNvSpPr txBox="1"/>
           <p:nvPr/>
         </p:nvSpPr>
         <p:spPr>
           <a:xfrm>
-            <a:off x="6537960" y="2560320"/>
-            <a:ext cx="4754880" cy="3200400"/>
+            <a:off x="3429000" y="3977640"/>
+            <a:ext cx="2560320" cy="1280160"/>
           </a:xfrm>
           <a:prstGeom prst="rect">
             <a:avLst/>
@@ -3133,65 +2882,312 @@
           <a:bodyPr wrap="square" lIns="0" tIns="0" rIns="0" bIns="0" rtlCol="0" anchor="t"/>
           <a:lstStyle/>
           <a:p>
-            <a:pPr marL="342900" indent="-342900">
-              <a:spcAft>
-                <a:spcPts val="1000"/>
-              </a:spcAft>
-              <a:buSzPct val="100000"/>
-              <a:buChar char="•"/>
-            </a:pPr>
-            <a:r>
-              <a:rPr lang="en-US" sz="1500" dirty="0">
-                <a:solidFill>
-                  <a:srgbClr val="22261C"/>
+            <a:pPr algn="ctr" indent="0" marL="0">
+              <a:buNone/>
+            </a:pPr>
+            <a:r>
+              <a:rPr lang="en-US" sz="1400" dirty="0">
+                <a:solidFill>
+                  <a:srgbClr val="6B6A5C"/>
                 </a:solidFill>
                 <a:latin typeface="Calibri" pitchFamily="34" charset="0"/>
                 <a:ea typeface="Calibri" pitchFamily="34" charset="-122"/>
                 <a:cs typeface="Calibri" pitchFamily="34" charset="-120"/>
               </a:rPr>
-              <a:t>Humidité mesurée à 2 m, pas au feuillage : humectation estimée, non mesurée</a:t>
-            </a:r>
-            <a:endParaRPr lang="en-US" sz="1500" dirty="0"/>
-          </a:p>
-          <a:p>
-            <a:pPr marL="342900" indent="-342900">
-              <a:spcAft>
-                <a:spcPts val="1000"/>
-              </a:spcAft>
-              <a:buSzPct val="100000"/>
-              <a:buChar char="•"/>
-            </a:pPr>
-            <a:r>
-              <a:rPr lang="en-US" sz="1500" dirty="0">
+              <a:t>Selon saison et zone climatique, avec planification des cultures</a:t>
+            </a:r>
+            <a:endParaRPr lang="en-US" sz="1400" dirty="0"/>
+          </a:p>
+        </p:txBody>
+      </p:sp>
+      <p:sp>
+        <p:nvSpPr>
+          <p:cNvPr id="11" name="Shape 7"/>
+          <p:cNvSpPr/>
+          <p:nvPr/>
+        </p:nvSpPr>
+        <p:spPr>
+          <a:xfrm>
+            <a:off x="6995160" y="1828800"/>
+            <a:ext cx="1005840" cy="1005840"/>
+          </a:xfrm>
+          <a:prstGeom prst="ellipse">
+            <a:avLst/>
+          </a:prstGeom>
+          <a:solidFill>
+            <a:srgbClr val="2B3A1F"/>
+          </a:solidFill>
+          <a:ln w="12700">
+            <a:solidFill>
+              <a:srgbClr val="2B3A1F"/>
+            </a:solidFill>
+            <a:prstDash val="solid"/>
+          </a:ln>
+        </p:spPr>
+      </p:sp>
+      <p:pic>
+        <p:nvPicPr>
+          <p:cNvPr id="12" name="Image 2" descr="preencoded.png">    </p:cNvPr>
+          <p:cNvPicPr>
+            <a:picLocks noChangeAspect="1"/>
+          </p:cNvPicPr>
+          <p:nvPr/>
+        </p:nvPicPr>
+        <p:blipFill>
+          <a:blip r:embed="rId3"/>
+          <a:stretch>
+            <a:fillRect/>
+          </a:stretch>
+        </p:blipFill>
+        <p:spPr>
+          <a:xfrm>
+            <a:off x="7246620" y="2080260"/>
+            <a:ext cx="502920" cy="502920"/>
+          </a:xfrm>
+          <a:prstGeom prst="rect">
+            <a:avLst/>
+          </a:prstGeom>
+        </p:spPr>
+      </p:pic>
+      <p:sp>
+        <p:nvSpPr>
+          <p:cNvPr id="13" name="Text 8"/>
+          <p:cNvSpPr txBox="1"/>
+          <p:nvPr/>
+        </p:nvSpPr>
+        <p:spPr>
+          <a:xfrm>
+            <a:off x="6217920" y="3108960"/>
+            <a:ext cx="2560320" cy="822960"/>
+          </a:xfrm>
+          <a:prstGeom prst="rect">
+            <a:avLst/>
+          </a:prstGeom>
+          <a:noFill/>
+          <a:ln/>
+        </p:spPr>
+        <p:txBody>
+          <a:bodyPr wrap="square" lIns="0" tIns="0" rIns="0" bIns="0" rtlCol="0" anchor="t"/>
+          <a:lstStyle/>
+          <a:p>
+            <a:pPr algn="ctr" indent="0" marL="0">
+              <a:buNone/>
+            </a:pPr>
+            <a:r>
+              <a:rPr lang="en-US" sz="1800" b="1" dirty="0">
                 <a:solidFill>
                   <a:srgbClr val="22261C"/>
+                </a:solidFill>
+                <a:latin typeface="Cambria" pitchFamily="34" charset="0"/>
+                <a:ea typeface="Cambria" pitchFamily="34" charset="-122"/>
+                <a:cs typeface="Cambria" pitchFamily="34" charset="-120"/>
+              </a:rPr>
+              <a:t>Carnet de suivi sanitaire</a:t>
+            </a:r>
+            <a:endParaRPr lang="en-US" sz="1800" dirty="0"/>
+          </a:p>
+        </p:txBody>
+      </p:sp>
+      <p:sp>
+        <p:nvSpPr>
+          <p:cNvPr id="14" name="Text 9"/>
+          <p:cNvSpPr txBox="1"/>
+          <p:nvPr/>
+        </p:nvSpPr>
+        <p:spPr>
+          <a:xfrm>
+            <a:off x="6217920" y="3977640"/>
+            <a:ext cx="2560320" cy="1280160"/>
+          </a:xfrm>
+          <a:prstGeom prst="rect">
+            <a:avLst/>
+          </a:prstGeom>
+          <a:noFill/>
+          <a:ln/>
+        </p:spPr>
+        <p:txBody>
+          <a:bodyPr wrap="square" lIns="0" tIns="0" rIns="0" bIns="0" rtlCol="0" anchor="t"/>
+          <a:lstStyle/>
+          <a:p>
+            <a:pPr algn="ctr" indent="0" marL="0">
+              <a:buNone/>
+            </a:pPr>
+            <a:r>
+              <a:rPr lang="en-US" sz="1400" dirty="0">
+                <a:solidFill>
+                  <a:srgbClr val="6B6A5C"/>
                 </a:solidFill>
                 <a:latin typeface="Calibri" pitchFamily="34" charset="0"/>
                 <a:ea typeface="Calibri" pitchFamily="34" charset="-122"/>
                 <a:cs typeface="Calibri" pitchFamily="34" charset="-120"/>
               </a:rPr>
-              <a:t>Virus (CMV, TSWV, TMV…) sans seuils climatiques : pas d'alerte automatique</a:t>
-            </a:r>
-            <a:endParaRPr lang="en-US" sz="1500" dirty="0"/>
-          </a:p>
-          <a:p>
-            <a:pPr marL="342900" indent="-342900">
-              <a:spcAft>
-                <a:spcPts val="1000"/>
-              </a:spcAft>
-              <a:buSzPct val="100000"/>
-              <a:buChar char="•"/>
-            </a:pPr>
-            <a:r>
-              <a:rPr lang="en-US" sz="1500" dirty="0">
+              <a:t>Pour chaque culture suivie : maladie observée ou non, traitement réalisé (date, produit, notes)</a:t>
+            </a:r>
+            <a:endParaRPr lang="en-US" sz="1400" dirty="0"/>
+          </a:p>
+        </p:txBody>
+      </p:sp>
+      <p:sp>
+        <p:nvSpPr>
+          <p:cNvPr id="15" name="Shape 10"/>
+          <p:cNvSpPr/>
+          <p:nvPr/>
+        </p:nvSpPr>
+        <p:spPr>
+          <a:xfrm>
+            <a:off x="9784080" y="1828800"/>
+            <a:ext cx="1005840" cy="1005840"/>
+          </a:xfrm>
+          <a:prstGeom prst="ellipse">
+            <a:avLst/>
+          </a:prstGeom>
+          <a:solidFill>
+            <a:srgbClr val="2B3A1F"/>
+          </a:solidFill>
+          <a:ln w="12700">
+            <a:solidFill>
+              <a:srgbClr val="2B3A1F"/>
+            </a:solidFill>
+            <a:prstDash val="solid"/>
+          </a:ln>
+        </p:spPr>
+      </p:sp>
+      <p:pic>
+        <p:nvPicPr>
+          <p:cNvPr id="16" name="Image 3" descr="preencoded.png">    </p:cNvPr>
+          <p:cNvPicPr>
+            <a:picLocks noChangeAspect="1"/>
+          </p:cNvPicPr>
+          <p:nvPr/>
+        </p:nvPicPr>
+        <p:blipFill>
+          <a:blip r:embed="rId4"/>
+          <a:stretch>
+            <a:fillRect/>
+          </a:stretch>
+        </p:blipFill>
+        <p:spPr>
+          <a:xfrm>
+            <a:off x="10035540" y="2080260"/>
+            <a:ext cx="502920" cy="502920"/>
+          </a:xfrm>
+          <a:prstGeom prst="rect">
+            <a:avLst/>
+          </a:prstGeom>
+        </p:spPr>
+      </p:pic>
+      <p:sp>
+        <p:nvSpPr>
+          <p:cNvPr id="17" name="Text 11"/>
+          <p:cNvSpPr txBox="1"/>
+          <p:nvPr/>
+        </p:nvSpPr>
+        <p:spPr>
+          <a:xfrm>
+            <a:off x="9006840" y="3108960"/>
+            <a:ext cx="2560320" cy="822960"/>
+          </a:xfrm>
+          <a:prstGeom prst="rect">
+            <a:avLst/>
+          </a:prstGeom>
+          <a:noFill/>
+          <a:ln/>
+        </p:spPr>
+        <p:txBody>
+          <a:bodyPr wrap="square" lIns="0" tIns="0" rIns="0" bIns="0" rtlCol="0" anchor="t"/>
+          <a:lstStyle/>
+          <a:p>
+            <a:pPr algn="ctr" indent="0" marL="0">
+              <a:buNone/>
+            </a:pPr>
+            <a:r>
+              <a:rPr lang="en-US" sz="1800" b="1" dirty="0">
                 <a:solidFill>
                   <a:srgbClr val="22261C"/>
+                </a:solidFill>
+                <a:latin typeface="Cambria" pitchFamily="34" charset="0"/>
+                <a:ea typeface="Cambria" pitchFamily="34" charset="-122"/>
+                <a:cs typeface="Cambria" pitchFamily="34" charset="-120"/>
+              </a:rPr>
+              <a:t>Historique des alertes</a:t>
+            </a:r>
+            <a:endParaRPr lang="en-US" sz="1800" dirty="0"/>
+          </a:p>
+        </p:txBody>
+      </p:sp>
+      <p:sp>
+        <p:nvSpPr>
+          <p:cNvPr id="18" name="Text 12"/>
+          <p:cNvSpPr txBox="1"/>
+          <p:nvPr/>
+        </p:nvSpPr>
+        <p:spPr>
+          <a:xfrm>
+            <a:off x="9006840" y="3977640"/>
+            <a:ext cx="2560320" cy="1280160"/>
+          </a:xfrm>
+          <a:prstGeom prst="rect">
+            <a:avLst/>
+          </a:prstGeom>
+          <a:noFill/>
+          <a:ln/>
+        </p:spPr>
+        <p:txBody>
+          <a:bodyPr wrap="square" lIns="0" tIns="0" rIns="0" bIns="0" rtlCol="0" anchor="t"/>
+          <a:lstStyle/>
+          <a:p>
+            <a:pPr algn="ctr" indent="0" marL="0">
+              <a:buNone/>
+            </a:pPr>
+            <a:r>
+              <a:rPr lang="en-US" sz="1400" dirty="0">
+                <a:solidFill>
+                  <a:srgbClr val="6B6A5C"/>
                 </a:solidFill>
                 <a:latin typeface="Calibri" pitchFamily="34" charset="0"/>
                 <a:ea typeface="Calibri" pitchFamily="34" charset="-122"/>
                 <a:cs typeface="Calibri" pitchFamily="34" charset="-120"/>
               </a:rPr>
-              <a:t>Seuils volontairement prudents : aide à la décision, pas prescription</a:t>
+              <a:t>Confronter alertes et observations pour confirmer, saison après saison, l'utilité des interventions préventives</a:t>
+            </a:r>
+            <a:endParaRPr lang="en-US" sz="1400" dirty="0"/>
+          </a:p>
+        </p:txBody>
+      </p:sp>
+      <p:sp>
+        <p:nvSpPr>
+          <p:cNvPr id="19" name="Text 13"/>
+          <p:cNvSpPr txBox="1"/>
+          <p:nvPr/>
+        </p:nvSpPr>
+        <p:spPr>
+          <a:xfrm>
+            <a:off x="640080" y="5486400"/>
+            <a:ext cx="10881360" cy="548640"/>
+          </a:xfrm>
+          <a:prstGeom prst="rect">
+            <a:avLst/>
+          </a:prstGeom>
+          <a:noFill/>
+          <a:ln/>
+        </p:spPr>
+        <p:txBody>
+          <a:bodyPr wrap="square" lIns="0" tIns="0" rIns="0" bIns="0" rtlCol="0" anchor="ctr"/>
+          <a:lstStyle/>
+          <a:p>
+            <a:pPr indent="0" marL="0">
+              <a:buNone/>
+            </a:pPr>
+            <a:r>
+              <a:rPr lang="en-US" sz="1500" i="1" dirty="0">
+                <a:solidFill>
+                  <a:srgbClr val="A0472A"/>
+                </a:solidFill>
+                <a:latin typeface="Calibri" pitchFamily="34" charset="0"/>
+                <a:ea typeface="Calibri" pitchFamily="34" charset="-122"/>
+                <a:cs typeface="Calibri" pitchFamily="34" charset="-120"/>
+              </a:rPr>
+              <a:t>À discuter : partenariats (GAB, lycées agricoles, collectivités), tests utilisateurs, validation agronomique.</a:t>
             </a:r>
             <a:endParaRPr lang="en-US" sz="1500" dirty="0"/>
           </a:p>
@@ -3208,638 +3204,6 @@
 <file path=ppt/slides/slide11.xml><?xml version="1.0" encoding="utf-8"?>
 <p:sld xmlns:a="http://schemas.openxmlformats.org/drawingml/2006/main" xmlns:r="http://schemas.openxmlformats.org/officeDocument/2006/relationships" xmlns:p="http://schemas.openxmlformats.org/presentationml/2006/main">
   <p:cSld name="Slide 11">
-    <p:bg>
-      <p:bgPr>
-        <a:solidFill>
-          <a:srgbClr val="F2EEE3"/>
-        </a:solidFill>
-      </p:bgPr>
-    </p:bg>
-    <p:spTree>
-      <p:nvGrpSpPr>
-        <p:cNvPr id="1" name=""/>
-        <p:cNvGrpSpPr/>
-        <p:nvPr/>
-      </p:nvGrpSpPr>
-      <p:grpSpPr>
-        <a:xfrm>
-          <a:off x="0" y="0"/>
-          <a:ext cx="0" cy="0"/>
-          <a:chOff x="0" y="0"/>
-          <a:chExt cx="0" cy="0"/>
-        </a:xfrm>
-      </p:grpSpPr>
-      <p:sp>
-        <p:nvSpPr>
-          <p:cNvPr id="2" name="Text 0"/>
-          <p:cNvSpPr txBox="1"/>
-          <p:nvPr/>
-        </p:nvSpPr>
-        <p:spPr>
-          <a:xfrm>
-            <a:off x="640080" y="457200"/>
-            <a:ext cx="10881360" cy="731520"/>
-          </a:xfrm>
-          <a:prstGeom prst="rect">
-            <a:avLst/>
-          </a:prstGeom>
-          <a:noFill/>
-          <a:ln/>
-        </p:spPr>
-        <p:txBody>
-          <a:bodyPr wrap="square" lIns="0" tIns="0" rIns="0" bIns="0" rtlCol="0" anchor="ctr"/>
-          <a:lstStyle/>
-          <a:p>
-            <a:pPr indent="0" marL="0">
-              <a:buNone/>
-            </a:pPr>
-            <a:r>
-              <a:rPr lang="en-US" sz="3600" dirty="0">
-                <a:solidFill>
-                  <a:srgbClr val="22261C"/>
-                </a:solidFill>
-                <a:latin typeface="Cambria" pitchFamily="34" charset="0"/>
-                <a:ea typeface="Cambria" pitchFamily="34" charset="-122"/>
-                <a:cs typeface="Cambria" pitchFamily="34" charset="-120"/>
-              </a:rPr>
-              <a:t>Perspectives </a:t>
-            </a:r>
-            <a:pPr indent="0" marL="0">
-              <a:buNone/>
-            </a:pPr>
-            <a:r>
-              <a:rPr lang="en-US" sz="3600" i="1" dirty="0">
-                <a:solidFill>
-                  <a:srgbClr val="A0472A"/>
-                </a:solidFill>
-                <a:latin typeface="Cambria" pitchFamily="34" charset="0"/>
-                <a:ea typeface="Cambria" pitchFamily="34" charset="-122"/>
-                <a:cs typeface="Cambria" pitchFamily="34" charset="-120"/>
-              </a:rPr>
-              <a:t>d'évolution</a:t>
-            </a:r>
-            <a:endParaRPr lang="en-US" sz="3600" dirty="0"/>
-          </a:p>
-        </p:txBody>
-      </p:sp>
-      <p:sp>
-        <p:nvSpPr>
-          <p:cNvPr id="3" name="Shape 1"/>
-          <p:cNvSpPr/>
-          <p:nvPr/>
-        </p:nvSpPr>
-        <p:spPr>
-          <a:xfrm>
-            <a:off x="1417320" y="1828800"/>
-            <a:ext cx="1005840" cy="1005840"/>
-          </a:xfrm>
-          <a:prstGeom prst="ellipse">
-            <a:avLst/>
-          </a:prstGeom>
-          <a:solidFill>
-            <a:srgbClr val="A0472A"/>
-          </a:solidFill>
-          <a:ln w="12700">
-            <a:solidFill>
-              <a:srgbClr val="A0472A"/>
-            </a:solidFill>
-            <a:prstDash val="solid"/>
-          </a:ln>
-        </p:spPr>
-      </p:sp>
-      <p:pic>
-        <p:nvPicPr>
-          <p:cNvPr id="4" name="Image 0" descr="preencoded.png">    </p:cNvPr>
-          <p:cNvPicPr>
-            <a:picLocks noChangeAspect="1"/>
-          </p:cNvPicPr>
-          <p:nvPr/>
-        </p:nvPicPr>
-        <p:blipFill>
-          <a:blip r:embed="rId1"/>
-          <a:stretch>
-            <a:fillRect/>
-          </a:stretch>
-        </p:blipFill>
-        <p:spPr>
-          <a:xfrm>
-            <a:off x="1668780" y="2080260"/>
-            <a:ext cx="502920" cy="502920"/>
-          </a:xfrm>
-          <a:prstGeom prst="rect">
-            <a:avLst/>
-          </a:prstGeom>
-        </p:spPr>
-      </p:pic>
-      <p:sp>
-        <p:nvSpPr>
-          <p:cNvPr id="5" name="Text 2"/>
-          <p:cNvSpPr txBox="1"/>
-          <p:nvPr/>
-        </p:nvSpPr>
-        <p:spPr>
-          <a:xfrm>
-            <a:off x="640080" y="3108960"/>
-            <a:ext cx="2560320" cy="822960"/>
-          </a:xfrm>
-          <a:prstGeom prst="rect">
-            <a:avLst/>
-          </a:prstGeom>
-          <a:noFill/>
-          <a:ln/>
-        </p:spPr>
-        <p:txBody>
-          <a:bodyPr wrap="square" lIns="0" tIns="0" rIns="0" bIns="0" rtlCol="0" anchor="t"/>
-          <a:lstStyle/>
-          <a:p>
-            <a:pPr algn="ctr" indent="0" marL="0">
-              <a:buNone/>
-            </a:pPr>
-            <a:r>
-              <a:rPr lang="en-US" sz="1800" b="1" dirty="0">
-                <a:solidFill>
-                  <a:srgbClr val="22261C"/>
-                </a:solidFill>
-                <a:latin typeface="Cambria" pitchFamily="34" charset="0"/>
-                <a:ea typeface="Cambria" pitchFamily="34" charset="-122"/>
-                <a:cs typeface="Cambria" pitchFamily="34" charset="-120"/>
-              </a:rPr>
-              <a:t>Fruitiers / verger</a:t>
-            </a:r>
-            <a:endParaRPr lang="en-US" sz="1800" dirty="0"/>
-          </a:p>
-        </p:txBody>
-      </p:sp>
-      <p:sp>
-        <p:nvSpPr>
-          <p:cNvPr id="6" name="Text 3"/>
-          <p:cNvSpPr txBox="1"/>
-          <p:nvPr/>
-        </p:nvSpPr>
-        <p:spPr>
-          <a:xfrm>
-            <a:off x="640080" y="3977640"/>
-            <a:ext cx="2560320" cy="1280160"/>
-          </a:xfrm>
-          <a:prstGeom prst="rect">
-            <a:avLst/>
-          </a:prstGeom>
-          <a:noFill/>
-          <a:ln/>
-        </p:spPr>
-        <p:txBody>
-          <a:bodyPr wrap="square" lIns="0" tIns="0" rIns="0" bIns="0" rtlCol="0" anchor="t"/>
-          <a:lstStyle/>
-          <a:p>
-            <a:pPr algn="ctr" indent="0" marL="0">
-              <a:buNone/>
-            </a:pPr>
-            <a:r>
-              <a:rPr lang="en-US" sz="1400" dirty="0">
-                <a:solidFill>
-                  <a:srgbClr val="6B6A5C"/>
-                </a:solidFill>
-                <a:latin typeface="Calibri" pitchFamily="34" charset="0"/>
-                <a:ea typeface="Calibri" pitchFamily="34" charset="-122"/>
-                <a:cs typeface="Calibri" pitchFamily="34" charset="-120"/>
-              </a:rPr>
-              <a:t>Étendre les fiches et les alertes aux arbres fruitiers</a:t>
-            </a:r>
-            <a:endParaRPr lang="en-US" sz="1400" dirty="0"/>
-          </a:p>
-        </p:txBody>
-      </p:sp>
-      <p:sp>
-        <p:nvSpPr>
-          <p:cNvPr id="7" name="Shape 4"/>
-          <p:cNvSpPr/>
-          <p:nvPr/>
-        </p:nvSpPr>
-        <p:spPr>
-          <a:xfrm>
-            <a:off x="4206240" y="1828800"/>
-            <a:ext cx="1005840" cy="1005840"/>
-          </a:xfrm>
-          <a:prstGeom prst="ellipse">
-            <a:avLst/>
-          </a:prstGeom>
-          <a:solidFill>
-            <a:srgbClr val="2B3A1F"/>
-          </a:solidFill>
-          <a:ln w="12700">
-            <a:solidFill>
-              <a:srgbClr val="2B3A1F"/>
-            </a:solidFill>
-            <a:prstDash val="solid"/>
-          </a:ln>
-        </p:spPr>
-      </p:sp>
-      <p:pic>
-        <p:nvPicPr>
-          <p:cNvPr id="8" name="Image 1" descr="preencoded.png">    </p:cNvPr>
-          <p:cNvPicPr>
-            <a:picLocks noChangeAspect="1"/>
-          </p:cNvPicPr>
-          <p:nvPr/>
-        </p:nvPicPr>
-        <p:blipFill>
-          <a:blip r:embed="rId2"/>
-          <a:stretch>
-            <a:fillRect/>
-          </a:stretch>
-        </p:blipFill>
-        <p:spPr>
-          <a:xfrm>
-            <a:off x="4457700" y="2080260"/>
-            <a:ext cx="502920" cy="502920"/>
-          </a:xfrm>
-          <a:prstGeom prst="rect">
-            <a:avLst/>
-          </a:prstGeom>
-        </p:spPr>
-      </p:pic>
-      <p:sp>
-        <p:nvSpPr>
-          <p:cNvPr id="9" name="Text 5"/>
-          <p:cNvSpPr txBox="1"/>
-          <p:nvPr/>
-        </p:nvSpPr>
-        <p:spPr>
-          <a:xfrm>
-            <a:off x="3429000" y="3108960"/>
-            <a:ext cx="2560320" cy="822960"/>
-          </a:xfrm>
-          <a:prstGeom prst="rect">
-            <a:avLst/>
-          </a:prstGeom>
-          <a:noFill/>
-          <a:ln/>
-        </p:spPr>
-        <p:txBody>
-          <a:bodyPr wrap="square" lIns="0" tIns="0" rIns="0" bIns="0" rtlCol="0" anchor="t"/>
-          <a:lstStyle/>
-          <a:p>
-            <a:pPr algn="ctr" indent="0" marL="0">
-              <a:buNone/>
-            </a:pPr>
-            <a:r>
-              <a:rPr lang="en-US" sz="1800" b="1" dirty="0">
-                <a:solidFill>
-                  <a:srgbClr val="22261C"/>
-                </a:solidFill>
-                <a:latin typeface="Cambria" pitchFamily="34" charset="0"/>
-                <a:ea typeface="Cambria" pitchFamily="34" charset="-122"/>
-                <a:cs typeface="Cambria" pitchFamily="34" charset="-120"/>
-              </a:rPr>
-              <a:t>Calendrier de semis local</a:t>
-            </a:r>
-            <a:endParaRPr lang="en-US" sz="1800" dirty="0"/>
-          </a:p>
-        </p:txBody>
-      </p:sp>
-      <p:sp>
-        <p:nvSpPr>
-          <p:cNvPr id="10" name="Text 6"/>
-          <p:cNvSpPr txBox="1"/>
-          <p:nvPr/>
-        </p:nvSpPr>
-        <p:spPr>
-          <a:xfrm>
-            <a:off x="3429000" y="3977640"/>
-            <a:ext cx="2560320" cy="1280160"/>
-          </a:xfrm>
-          <a:prstGeom prst="rect">
-            <a:avLst/>
-          </a:prstGeom>
-          <a:noFill/>
-          <a:ln/>
-        </p:spPr>
-        <p:txBody>
-          <a:bodyPr wrap="square" lIns="0" tIns="0" rIns="0" bIns="0" rtlCol="0" anchor="t"/>
-          <a:lstStyle/>
-          <a:p>
-            <a:pPr algn="ctr" indent="0" marL="0">
-              <a:buNone/>
-            </a:pPr>
-            <a:r>
-              <a:rPr lang="en-US" sz="1400" dirty="0">
-                <a:solidFill>
-                  <a:srgbClr val="6B6A5C"/>
-                </a:solidFill>
-                <a:latin typeface="Calibri" pitchFamily="34" charset="0"/>
-                <a:ea typeface="Calibri" pitchFamily="34" charset="-122"/>
-                <a:cs typeface="Calibri" pitchFamily="34" charset="-120"/>
-              </a:rPr>
-              <a:t>Selon saison et zone climatique, avec planification des cultures</a:t>
-            </a:r>
-            <a:endParaRPr lang="en-US" sz="1400" dirty="0"/>
-          </a:p>
-        </p:txBody>
-      </p:sp>
-      <p:sp>
-        <p:nvSpPr>
-          <p:cNvPr id="11" name="Shape 7"/>
-          <p:cNvSpPr/>
-          <p:nvPr/>
-        </p:nvSpPr>
-        <p:spPr>
-          <a:xfrm>
-            <a:off x="6995160" y="1828800"/>
-            <a:ext cx="1005840" cy="1005840"/>
-          </a:xfrm>
-          <a:prstGeom prst="ellipse">
-            <a:avLst/>
-          </a:prstGeom>
-          <a:solidFill>
-            <a:srgbClr val="2B3A1F"/>
-          </a:solidFill>
-          <a:ln w="12700">
-            <a:solidFill>
-              <a:srgbClr val="2B3A1F"/>
-            </a:solidFill>
-            <a:prstDash val="solid"/>
-          </a:ln>
-        </p:spPr>
-      </p:sp>
-      <p:pic>
-        <p:nvPicPr>
-          <p:cNvPr id="12" name="Image 2" descr="preencoded.png">    </p:cNvPr>
-          <p:cNvPicPr>
-            <a:picLocks noChangeAspect="1"/>
-          </p:cNvPicPr>
-          <p:nvPr/>
-        </p:nvPicPr>
-        <p:blipFill>
-          <a:blip r:embed="rId3"/>
-          <a:stretch>
-            <a:fillRect/>
-          </a:stretch>
-        </p:blipFill>
-        <p:spPr>
-          <a:xfrm>
-            <a:off x="7246620" y="2080260"/>
-            <a:ext cx="502920" cy="502920"/>
-          </a:xfrm>
-          <a:prstGeom prst="rect">
-            <a:avLst/>
-          </a:prstGeom>
-        </p:spPr>
-      </p:pic>
-      <p:sp>
-        <p:nvSpPr>
-          <p:cNvPr id="13" name="Text 8"/>
-          <p:cNvSpPr txBox="1"/>
-          <p:nvPr/>
-        </p:nvSpPr>
-        <p:spPr>
-          <a:xfrm>
-            <a:off x="6217920" y="3108960"/>
-            <a:ext cx="2560320" cy="822960"/>
-          </a:xfrm>
-          <a:prstGeom prst="rect">
-            <a:avLst/>
-          </a:prstGeom>
-          <a:noFill/>
-          <a:ln/>
-        </p:spPr>
-        <p:txBody>
-          <a:bodyPr wrap="square" lIns="0" tIns="0" rIns="0" bIns="0" rtlCol="0" anchor="t"/>
-          <a:lstStyle/>
-          <a:p>
-            <a:pPr algn="ctr" indent="0" marL="0">
-              <a:buNone/>
-            </a:pPr>
-            <a:r>
-              <a:rPr lang="en-US" sz="1800" b="1" dirty="0">
-                <a:solidFill>
-                  <a:srgbClr val="22261C"/>
-                </a:solidFill>
-                <a:latin typeface="Cambria" pitchFamily="34" charset="0"/>
-                <a:ea typeface="Cambria" pitchFamily="34" charset="-122"/>
-                <a:cs typeface="Cambria" pitchFamily="34" charset="-120"/>
-              </a:rPr>
-              <a:t>Carnet de suivi sanitaire</a:t>
-            </a:r>
-            <a:endParaRPr lang="en-US" sz="1800" dirty="0"/>
-          </a:p>
-        </p:txBody>
-      </p:sp>
-      <p:sp>
-        <p:nvSpPr>
-          <p:cNvPr id="14" name="Text 9"/>
-          <p:cNvSpPr txBox="1"/>
-          <p:nvPr/>
-        </p:nvSpPr>
-        <p:spPr>
-          <a:xfrm>
-            <a:off x="6217920" y="3977640"/>
-            <a:ext cx="2560320" cy="1280160"/>
-          </a:xfrm>
-          <a:prstGeom prst="rect">
-            <a:avLst/>
-          </a:prstGeom>
-          <a:noFill/>
-          <a:ln/>
-        </p:spPr>
-        <p:txBody>
-          <a:bodyPr wrap="square" lIns="0" tIns="0" rIns="0" bIns="0" rtlCol="0" anchor="t"/>
-          <a:lstStyle/>
-          <a:p>
-            <a:pPr algn="ctr" indent="0" marL="0">
-              <a:buNone/>
-            </a:pPr>
-            <a:r>
-              <a:rPr lang="en-US" sz="1400" dirty="0">
-                <a:solidFill>
-                  <a:srgbClr val="6B6A5C"/>
-                </a:solidFill>
-                <a:latin typeface="Calibri" pitchFamily="34" charset="0"/>
-                <a:ea typeface="Calibri" pitchFamily="34" charset="-122"/>
-                <a:cs typeface="Calibri" pitchFamily="34" charset="-120"/>
-              </a:rPr>
-              <a:t>Pour chaque culture suivie : maladie observée ou non, traitement réalisé (date, produit, notes)</a:t>
-            </a:r>
-            <a:endParaRPr lang="en-US" sz="1400" dirty="0"/>
-          </a:p>
-        </p:txBody>
-      </p:sp>
-      <p:sp>
-        <p:nvSpPr>
-          <p:cNvPr id="15" name="Shape 10"/>
-          <p:cNvSpPr/>
-          <p:nvPr/>
-        </p:nvSpPr>
-        <p:spPr>
-          <a:xfrm>
-            <a:off x="9784080" y="1828800"/>
-            <a:ext cx="1005840" cy="1005840"/>
-          </a:xfrm>
-          <a:prstGeom prst="ellipse">
-            <a:avLst/>
-          </a:prstGeom>
-          <a:solidFill>
-            <a:srgbClr val="2B3A1F"/>
-          </a:solidFill>
-          <a:ln w="12700">
-            <a:solidFill>
-              <a:srgbClr val="2B3A1F"/>
-            </a:solidFill>
-            <a:prstDash val="solid"/>
-          </a:ln>
-        </p:spPr>
-      </p:sp>
-      <p:pic>
-        <p:nvPicPr>
-          <p:cNvPr id="16" name="Image 3" descr="preencoded.png">    </p:cNvPr>
-          <p:cNvPicPr>
-            <a:picLocks noChangeAspect="1"/>
-          </p:cNvPicPr>
-          <p:nvPr/>
-        </p:nvPicPr>
-        <p:blipFill>
-          <a:blip r:embed="rId4"/>
-          <a:stretch>
-            <a:fillRect/>
-          </a:stretch>
-        </p:blipFill>
-        <p:spPr>
-          <a:xfrm>
-            <a:off x="10035540" y="2080260"/>
-            <a:ext cx="502920" cy="502920"/>
-          </a:xfrm>
-          <a:prstGeom prst="rect">
-            <a:avLst/>
-          </a:prstGeom>
-        </p:spPr>
-      </p:pic>
-      <p:sp>
-        <p:nvSpPr>
-          <p:cNvPr id="17" name="Text 11"/>
-          <p:cNvSpPr txBox="1"/>
-          <p:nvPr/>
-        </p:nvSpPr>
-        <p:spPr>
-          <a:xfrm>
-            <a:off x="9006840" y="3108960"/>
-            <a:ext cx="2560320" cy="822960"/>
-          </a:xfrm>
-          <a:prstGeom prst="rect">
-            <a:avLst/>
-          </a:prstGeom>
-          <a:noFill/>
-          <a:ln/>
-        </p:spPr>
-        <p:txBody>
-          <a:bodyPr wrap="square" lIns="0" tIns="0" rIns="0" bIns="0" rtlCol="0" anchor="t"/>
-          <a:lstStyle/>
-          <a:p>
-            <a:pPr algn="ctr" indent="0" marL="0">
-              <a:buNone/>
-            </a:pPr>
-            <a:r>
-              <a:rPr lang="en-US" sz="1800" b="1" dirty="0">
-                <a:solidFill>
-                  <a:srgbClr val="22261C"/>
-                </a:solidFill>
-                <a:latin typeface="Cambria" pitchFamily="34" charset="0"/>
-                <a:ea typeface="Cambria" pitchFamily="34" charset="-122"/>
-                <a:cs typeface="Cambria" pitchFamily="34" charset="-120"/>
-              </a:rPr>
-              <a:t>Historique des alertes</a:t>
-            </a:r>
-            <a:endParaRPr lang="en-US" sz="1800" dirty="0"/>
-          </a:p>
-        </p:txBody>
-      </p:sp>
-      <p:sp>
-        <p:nvSpPr>
-          <p:cNvPr id="18" name="Text 12"/>
-          <p:cNvSpPr txBox="1"/>
-          <p:nvPr/>
-        </p:nvSpPr>
-        <p:spPr>
-          <a:xfrm>
-            <a:off x="9006840" y="3977640"/>
-            <a:ext cx="2560320" cy="1280160"/>
-          </a:xfrm>
-          <a:prstGeom prst="rect">
-            <a:avLst/>
-          </a:prstGeom>
-          <a:noFill/>
-          <a:ln/>
-        </p:spPr>
-        <p:txBody>
-          <a:bodyPr wrap="square" lIns="0" tIns="0" rIns="0" bIns="0" rtlCol="0" anchor="t"/>
-          <a:lstStyle/>
-          <a:p>
-            <a:pPr algn="ctr" indent="0" marL="0">
-              <a:buNone/>
-            </a:pPr>
-            <a:r>
-              <a:rPr lang="en-US" sz="1400" dirty="0">
-                <a:solidFill>
-                  <a:srgbClr val="6B6A5C"/>
-                </a:solidFill>
-                <a:latin typeface="Calibri" pitchFamily="34" charset="0"/>
-                <a:ea typeface="Calibri" pitchFamily="34" charset="-122"/>
-                <a:cs typeface="Calibri" pitchFamily="34" charset="-120"/>
-              </a:rPr>
-              <a:t>Confronter alertes et observations pour confirmer, saison après saison, l'utilité des interventions préventives</a:t>
-            </a:r>
-            <a:endParaRPr lang="en-US" sz="1400" dirty="0"/>
-          </a:p>
-        </p:txBody>
-      </p:sp>
-      <p:sp>
-        <p:nvSpPr>
-          <p:cNvPr id="19" name="Text 13"/>
-          <p:cNvSpPr txBox="1"/>
-          <p:nvPr/>
-        </p:nvSpPr>
-        <p:spPr>
-          <a:xfrm>
-            <a:off x="640080" y="5486400"/>
-            <a:ext cx="10881360" cy="548640"/>
-          </a:xfrm>
-          <a:prstGeom prst="rect">
-            <a:avLst/>
-          </a:prstGeom>
-          <a:noFill/>
-          <a:ln/>
-        </p:spPr>
-        <p:txBody>
-          <a:bodyPr wrap="square" lIns="0" tIns="0" rIns="0" bIns="0" rtlCol="0" anchor="ctr"/>
-          <a:lstStyle/>
-          <a:p>
-            <a:pPr indent="0" marL="0">
-              <a:buNone/>
-            </a:pPr>
-            <a:r>
-              <a:rPr lang="en-US" sz="1500" i="1" dirty="0">
-                <a:solidFill>
-                  <a:srgbClr val="A0472A"/>
-                </a:solidFill>
-                <a:latin typeface="Calibri" pitchFamily="34" charset="0"/>
-                <a:ea typeface="Calibri" pitchFamily="34" charset="-122"/>
-                <a:cs typeface="Calibri" pitchFamily="34" charset="-120"/>
-              </a:rPr>
-              <a:t>À discuter : partenariats (GAB, lycées agricoles, collectivités), tests utilisateurs, validation agronomique.</a:t>
-            </a:r>
-            <a:endParaRPr lang="en-US" sz="1500" dirty="0"/>
-          </a:p>
-        </p:txBody>
-      </p:sp>
-    </p:spTree>
-  </p:cSld>
-  <p:clrMapOvr>
-    <a:masterClrMapping/>
-  </p:clrMapOvr>
-</p:sld>
-</file>
-
-<file path=ppt/slides/slide12.xml><?xml version="1.0" encoding="utf-8"?>
-<p:sld xmlns:a="http://schemas.openxmlformats.org/drawingml/2006/main" xmlns:r="http://schemas.openxmlformats.org/officeDocument/2006/relationships" xmlns:p="http://schemas.openxmlformats.org/presentationml/2006/main">
-  <p:cSld name="Slide 12">
     <p:bg>
       <p:bgPr>
         <a:solidFill>
@@ -8434,7 +7798,7 @@
     <p:bg>
       <p:bgPr>
         <a:solidFill>
-          <a:srgbClr val="2B3A1F"/>
+          <a:srgbClr val="F2EEE3"/>
         </a:solidFill>
       </p:bgPr>
     </p:bg>
@@ -8479,13 +7843,13 @@
             <a:r>
               <a:rPr lang="en-US" sz="3600" dirty="0">
                 <a:solidFill>
-                  <a:srgbClr val="FFFFFF"/>
+                  <a:srgbClr val="22261C"/>
                 </a:solidFill>
                 <a:latin typeface="Cambria" pitchFamily="34" charset="0"/>
                 <a:ea typeface="Cambria" pitchFamily="34" charset="-122"/>
                 <a:cs typeface="Cambria" pitchFamily="34" charset="-120"/>
               </a:rPr>
-              <a:t>L'outil </a:t>
+              <a:t>Sobriété </a:t>
             </a:r>
             <a:pPr indent="0" marL="0">
               <a:buNone/>
@@ -8493,13 +7857,13 @@
             <a:r>
               <a:rPr lang="en-US" sz="3600" i="1" dirty="0">
                 <a:solidFill>
-                  <a:srgbClr val="D9C48E"/>
+                  <a:srgbClr val="A0472A"/>
                 </a:solidFill>
                 <a:latin typeface="Cambria" pitchFamily="34" charset="0"/>
                 <a:ea typeface="Cambria" pitchFamily="34" charset="-122"/>
                 <a:cs typeface="Cambria" pitchFamily="34" charset="-120"/>
               </a:rPr>
-              <a:t>en chiffres</a:t>
+              <a:t>numérique par conception</a:t>
             </a:r>
             <a:endParaRPr lang="en-US" sz="3600" dirty="0"/>
           </a:p>
@@ -8507,14 +7871,97 @@
       </p:sp>
       <p:sp>
         <p:nvSpPr>
-          <p:cNvPr id="3" name="Text 1"/>
+          <p:cNvPr id="3" name="Shape 1"/>
+          <p:cNvSpPr/>
+          <p:nvPr/>
+        </p:nvSpPr>
+        <p:spPr>
+          <a:xfrm>
+            <a:off x="640080" y="1600200"/>
+            <a:ext cx="3429000" cy="2011680"/>
+          </a:xfrm>
+          <a:prstGeom prst="roundRect">
+            <a:avLst>
+              <a:gd name="adj" fmla="val 5455"/>
+            </a:avLst>
+          </a:prstGeom>
+          <a:solidFill>
+            <a:srgbClr val="FFFFFF"/>
+          </a:solidFill>
+          <a:ln w="9525">
+            <a:solidFill>
+              <a:srgbClr val="DCD5C3"/>
+            </a:solidFill>
+            <a:prstDash val="solid"/>
+          </a:ln>
+          <a:effectLst>
+            <a:outerShdw sx="100000" sy="100000" kx="0" ky="0" algn="bl" rotWithShape="0" blurRad="101600" dist="25400" dir="5400000">
+              <a:srgbClr val="000000">
+                <a:alpha val="12000"/>
+              </a:srgbClr>
+            </a:outerShdw>
+          </a:effectLst>
+        </p:spPr>
+      </p:sp>
+      <p:sp>
+        <p:nvSpPr>
+          <p:cNvPr id="4" name="Shape 2"/>
+          <p:cNvSpPr/>
+          <p:nvPr/>
+        </p:nvSpPr>
+        <p:spPr>
+          <a:xfrm>
+            <a:off x="914400" y="1874520"/>
+            <a:ext cx="640080" cy="640080"/>
+          </a:xfrm>
+          <a:prstGeom prst="ellipse">
+            <a:avLst/>
+          </a:prstGeom>
+          <a:solidFill>
+            <a:srgbClr val="2B3A1F"/>
+          </a:solidFill>
+          <a:ln w="12700">
+            <a:solidFill>
+              <a:srgbClr val="2B3A1F"/>
+            </a:solidFill>
+            <a:prstDash val="solid"/>
+          </a:ln>
+        </p:spPr>
+      </p:sp>
+      <p:pic>
+        <p:nvPicPr>
+          <p:cNvPr id="5" name="Image 0" descr="preencoded.png">    </p:cNvPr>
+          <p:cNvPicPr>
+            <a:picLocks noChangeAspect="1"/>
+          </p:cNvPicPr>
+          <p:nvPr/>
+        </p:nvPicPr>
+        <p:blipFill>
+          <a:blip r:embed="rId1"/>
+          <a:stretch>
+            <a:fillRect/>
+          </a:stretch>
+        </p:blipFill>
+        <p:spPr>
+          <a:xfrm>
+            <a:off x="1074420" y="2034540"/>
+            <a:ext cx="320040" cy="320040"/>
+          </a:xfrm>
+          <a:prstGeom prst="rect">
+            <a:avLst/>
+          </a:prstGeom>
+        </p:spPr>
+      </p:pic>
+      <p:sp>
+        <p:nvSpPr>
+          <p:cNvPr id="6" name="Text 3"/>
           <p:cNvSpPr txBox="1"/>
           <p:nvPr/>
         </p:nvSpPr>
         <p:spPr>
           <a:xfrm>
-            <a:off x="640080" y="2103120"/>
-            <a:ext cx="2560320" cy="1280160"/>
+            <a:off x="1691640" y="1920240"/>
+            <a:ext cx="2240280" cy="548640"/>
           </a:xfrm>
           <a:prstGeom prst="rect">
             <a:avLst/>
@@ -8530,54 +7977,15 @@
               <a:buNone/>
             </a:pPr>
             <a:r>
-              <a:rPr lang="en-US" sz="6600" b="1" dirty="0">
-                <a:solidFill>
-                  <a:srgbClr val="D9C48E"/>
-                </a:solidFill>
-                <a:latin typeface="Cambria" pitchFamily="34" charset="0"/>
-                <a:ea typeface="Cambria" pitchFamily="34" charset="-122"/>
-                <a:cs typeface="Cambria" pitchFamily="34" charset="-120"/>
-              </a:rPr>
-              <a:t>49</a:t>
-            </a:r>
-            <a:endParaRPr lang="en-US" sz="6600" dirty="0"/>
-          </a:p>
-        </p:txBody>
-      </p:sp>
-      <p:sp>
-        <p:nvSpPr>
-          <p:cNvPr id="4" name="Text 2"/>
-          <p:cNvSpPr txBox="1"/>
-          <p:nvPr/>
-        </p:nvSpPr>
-        <p:spPr>
-          <a:xfrm>
-            <a:off x="640080" y="3474720"/>
-            <a:ext cx="2377440" cy="731520"/>
-          </a:xfrm>
-          <a:prstGeom prst="rect">
-            <a:avLst/>
-          </a:prstGeom>
-          <a:noFill/>
-          <a:ln/>
-        </p:spPr>
-        <p:txBody>
-          <a:bodyPr wrap="square" lIns="0" tIns="0" rIns="0" bIns="0" rtlCol="0" anchor="t"/>
-          <a:lstStyle/>
-          <a:p>
-            <a:pPr indent="0" marL="0">
-              <a:buNone/>
-            </a:pPr>
-            <a:r>
-              <a:rPr lang="en-US" sz="1700" dirty="0">
-                <a:solidFill>
-                  <a:srgbClr val="E6E2D3"/>
+              <a:rPr lang="en-US" sz="1700" b="1" dirty="0">
+                <a:solidFill>
+                  <a:srgbClr val="22261C"/>
                 </a:solidFill>
                 <a:latin typeface="Calibri" pitchFamily="34" charset="0"/>
                 <a:ea typeface="Calibri" pitchFamily="34" charset="-122"/>
                 <a:cs typeface="Calibri" pitchFamily="34" charset="-120"/>
               </a:rPr>
-              <a:t>espèces documentées</a:t>
+              <a:t>Un seul fichier HTML</a:t>
             </a:r>
             <a:endParaRPr lang="en-US" sz="1700" dirty="0"/>
           </a:p>
@@ -8585,14 +7993,14 @@
       </p:sp>
       <p:sp>
         <p:nvSpPr>
-          <p:cNvPr id="5" name="Text 3"/>
+          <p:cNvPr id="7" name="Text 4"/>
           <p:cNvSpPr txBox="1"/>
           <p:nvPr/>
         </p:nvSpPr>
         <p:spPr>
           <a:xfrm>
-            <a:off x="3429000" y="2103120"/>
-            <a:ext cx="2560320" cy="1280160"/>
+            <a:off x="914400" y="2651760"/>
+            <a:ext cx="2926080" cy="822960"/>
           </a:xfrm>
           <a:prstGeom prst="rect">
             <a:avLst/>
@@ -8601,76 +8009,120 @@
           <a:ln/>
         </p:spPr>
         <p:txBody>
-          <a:bodyPr wrap="square" lIns="0" tIns="0" rIns="0" bIns="0" rtlCol="0" anchor="ctr"/>
+          <a:bodyPr wrap="square" lIns="0" tIns="0" rIns="0" bIns="0" rtlCol="0" anchor="t"/>
           <a:lstStyle/>
           <a:p>
             <a:pPr indent="0" marL="0">
               <a:buNone/>
             </a:pPr>
             <a:r>
-              <a:rPr lang="en-US" sz="6600" b="1" dirty="0">
-                <a:solidFill>
-                  <a:srgbClr val="D9C48E"/>
-                </a:solidFill>
-                <a:latin typeface="Cambria" pitchFamily="34" charset="0"/>
-                <a:ea typeface="Cambria" pitchFamily="34" charset="-122"/>
-                <a:cs typeface="Cambria" pitchFamily="34" charset="-120"/>
-              </a:rPr>
-              <a:t>40</a:t>
-            </a:r>
-            <a:endParaRPr lang="en-US" sz="6600" dirty="0"/>
-          </a:p>
-        </p:txBody>
-      </p:sp>
-      <p:sp>
-        <p:nvSpPr>
-          <p:cNvPr id="6" name="Text 4"/>
-          <p:cNvSpPr txBox="1"/>
-          <p:nvPr/>
-        </p:nvSpPr>
-        <p:spPr>
-          <a:xfrm>
-            <a:off x="3429000" y="3474720"/>
-            <a:ext cx="2377440" cy="731520"/>
-          </a:xfrm>
-          <a:prstGeom prst="rect">
-            <a:avLst/>
-          </a:prstGeom>
-          <a:noFill/>
-          <a:ln/>
-        </p:spPr>
-        <p:txBody>
-          <a:bodyPr wrap="square" lIns="0" tIns="0" rIns="0" bIns="0" rtlCol="0" anchor="t"/>
-          <a:lstStyle/>
-          <a:p>
-            <a:pPr indent="0" marL="0">
-              <a:buNone/>
-            </a:pPr>
-            <a:r>
-              <a:rPr lang="en-US" sz="1700" dirty="0">
-                <a:solidFill>
-                  <a:srgbClr val="E6E2D3"/>
+              <a:rPr lang="en-US" sz="1400" dirty="0">
+                <a:solidFill>
+                  <a:srgbClr val="6B6A5C"/>
                 </a:solidFill>
                 <a:latin typeface="Calibri" pitchFamily="34" charset="0"/>
                 <a:ea typeface="Calibri" pitchFamily="34" charset="-122"/>
                 <a:cs typeface="Calibri" pitchFamily="34" charset="-120"/>
               </a:rPr>
-              <a:t>maladies modélisées</a:t>
-            </a:r>
-            <a:endParaRPr lang="en-US" sz="1700" dirty="0"/>
-          </a:p>
-        </p:txBody>
-      </p:sp>
-      <p:sp>
-        <p:nvSpPr>
-          <p:cNvPr id="7" name="Text 5"/>
+              <a:t>Application statique, sans build, hébergée gratuitement sur GitHub Pages.</a:t>
+            </a:r>
+            <a:endParaRPr lang="en-US" sz="1400" dirty="0"/>
+          </a:p>
+        </p:txBody>
+      </p:sp>
+      <p:sp>
+        <p:nvSpPr>
+          <p:cNvPr id="8" name="Shape 5"/>
+          <p:cNvSpPr/>
+          <p:nvPr/>
+        </p:nvSpPr>
+        <p:spPr>
+          <a:xfrm>
+            <a:off x="4343400" y="1600200"/>
+            <a:ext cx="3429000" cy="2011680"/>
+          </a:xfrm>
+          <a:prstGeom prst="roundRect">
+            <a:avLst>
+              <a:gd name="adj" fmla="val 5455"/>
+            </a:avLst>
+          </a:prstGeom>
+          <a:solidFill>
+            <a:srgbClr val="FFFFFF"/>
+          </a:solidFill>
+          <a:ln w="9525">
+            <a:solidFill>
+              <a:srgbClr val="DCD5C3"/>
+            </a:solidFill>
+            <a:prstDash val="solid"/>
+          </a:ln>
+          <a:effectLst>
+            <a:outerShdw sx="100000" sy="100000" kx="0" ky="0" algn="bl" rotWithShape="0" blurRad="101600" dist="25400" dir="5400000">
+              <a:srgbClr val="000000">
+                <a:alpha val="12000"/>
+              </a:srgbClr>
+            </a:outerShdw>
+          </a:effectLst>
+        </p:spPr>
+      </p:sp>
+      <p:sp>
+        <p:nvSpPr>
+          <p:cNvPr id="9" name="Shape 6"/>
+          <p:cNvSpPr/>
+          <p:nvPr/>
+        </p:nvSpPr>
+        <p:spPr>
+          <a:xfrm>
+            <a:off x="4617720" y="1874520"/>
+            <a:ext cx="640080" cy="640080"/>
+          </a:xfrm>
+          <a:prstGeom prst="ellipse">
+            <a:avLst/>
+          </a:prstGeom>
+          <a:solidFill>
+            <a:srgbClr val="2B3A1F"/>
+          </a:solidFill>
+          <a:ln w="12700">
+            <a:solidFill>
+              <a:srgbClr val="2B3A1F"/>
+            </a:solidFill>
+            <a:prstDash val="solid"/>
+          </a:ln>
+        </p:spPr>
+      </p:sp>
+      <p:pic>
+        <p:nvPicPr>
+          <p:cNvPr id="10" name="Image 1" descr="preencoded.png">    </p:cNvPr>
+          <p:cNvPicPr>
+            <a:picLocks noChangeAspect="1"/>
+          </p:cNvPicPr>
+          <p:nvPr/>
+        </p:nvPicPr>
+        <p:blipFill>
+          <a:blip r:embed="rId2"/>
+          <a:stretch>
+            <a:fillRect/>
+          </a:stretch>
+        </p:blipFill>
+        <p:spPr>
+          <a:xfrm>
+            <a:off x="4777740" y="2034540"/>
+            <a:ext cx="320040" cy="320040"/>
+          </a:xfrm>
+          <a:prstGeom prst="rect">
+            <a:avLst/>
+          </a:prstGeom>
+        </p:spPr>
+      </p:pic>
+      <p:sp>
+        <p:nvSpPr>
+          <p:cNvPr id="11" name="Text 7"/>
           <p:cNvSpPr txBox="1"/>
           <p:nvPr/>
         </p:nvSpPr>
         <p:spPr>
           <a:xfrm>
-            <a:off x="6217920" y="2103120"/>
-            <a:ext cx="2560320" cy="1280160"/>
+            <a:off x="5394960" y="1920240"/>
+            <a:ext cx="2240280" cy="548640"/>
           </a:xfrm>
           <a:prstGeom prst="rect">
             <a:avLst/>
@@ -8686,54 +8138,15 @@
               <a:buNone/>
             </a:pPr>
             <a:r>
-              <a:rPr lang="en-US" sz="6600" b="1" dirty="0">
-                <a:solidFill>
-                  <a:srgbClr val="D9C48E"/>
-                </a:solidFill>
-                <a:latin typeface="Cambria" pitchFamily="34" charset="0"/>
-                <a:ea typeface="Cambria" pitchFamily="34" charset="-122"/>
-                <a:cs typeface="Cambria" pitchFamily="34" charset="-120"/>
-              </a:rPr>
-              <a:t>7 j</a:t>
-            </a:r>
-            <a:endParaRPr lang="en-US" sz="6600" dirty="0"/>
-          </a:p>
-        </p:txBody>
-      </p:sp>
-      <p:sp>
-        <p:nvSpPr>
-          <p:cNvPr id="8" name="Text 6"/>
-          <p:cNvSpPr txBox="1"/>
-          <p:nvPr/>
-        </p:nvSpPr>
-        <p:spPr>
-          <a:xfrm>
-            <a:off x="6217920" y="3474720"/>
-            <a:ext cx="2377440" cy="731520"/>
-          </a:xfrm>
-          <a:prstGeom prst="rect">
-            <a:avLst/>
-          </a:prstGeom>
-          <a:noFill/>
-          <a:ln/>
-        </p:spPr>
-        <p:txBody>
-          <a:bodyPr wrap="square" lIns="0" tIns="0" rIns="0" bIns="0" rtlCol="0" anchor="t"/>
-          <a:lstStyle/>
-          <a:p>
-            <a:pPr indent="0" marL="0">
-              <a:buNone/>
-            </a:pPr>
-            <a:r>
-              <a:rPr lang="en-US" sz="1700" dirty="0">
-                <a:solidFill>
-                  <a:srgbClr val="E6E2D3"/>
+              <a:rPr lang="en-US" sz="1700" b="1" dirty="0">
+                <a:solidFill>
+                  <a:srgbClr val="22261C"/>
                 </a:solidFill>
                 <a:latin typeface="Calibri" pitchFamily="34" charset="0"/>
                 <a:ea typeface="Calibri" pitchFamily="34" charset="-122"/>
                 <a:cs typeface="Calibri" pitchFamily="34" charset="-120"/>
               </a:rPr>
-              <a:t>de prévisions météo</a:t>
+              <a:t>Hors-ligne</a:t>
             </a:r>
             <a:endParaRPr lang="en-US" sz="1700" dirty="0"/>
           </a:p>
@@ -8741,14 +8154,14 @@
       </p:sp>
       <p:sp>
         <p:nvSpPr>
-          <p:cNvPr id="9" name="Text 7"/>
+          <p:cNvPr id="12" name="Text 8"/>
           <p:cNvSpPr txBox="1"/>
           <p:nvPr/>
         </p:nvSpPr>
         <p:spPr>
           <a:xfrm>
-            <a:off x="9006840" y="2103120"/>
-            <a:ext cx="2560320" cy="1280160"/>
+            <a:off x="4617720" y="2651760"/>
+            <a:ext cx="2926080" cy="822960"/>
           </a:xfrm>
           <a:prstGeom prst="rect">
             <a:avLst/>
@@ -8757,76 +8170,120 @@
           <a:ln/>
         </p:spPr>
         <p:txBody>
-          <a:bodyPr wrap="square" lIns="0" tIns="0" rIns="0" bIns="0" rtlCol="0" anchor="ctr"/>
+          <a:bodyPr wrap="square" lIns="0" tIns="0" rIns="0" bIns="0" rtlCol="0" anchor="t"/>
           <a:lstStyle/>
           <a:p>
             <a:pPr indent="0" marL="0">
               <a:buNone/>
             </a:pPr>
             <a:r>
-              <a:rPr lang="en-US" sz="6600" b="1" dirty="0">
-                <a:solidFill>
-                  <a:srgbClr val="D9C48E"/>
-                </a:solidFill>
-                <a:latin typeface="Cambria" pitchFamily="34" charset="0"/>
-                <a:ea typeface="Cambria" pitchFamily="34" charset="-122"/>
-                <a:cs typeface="Cambria" pitchFamily="34" charset="-120"/>
-              </a:rPr>
-              <a:t>0</a:t>
-            </a:r>
-            <a:endParaRPr lang="en-US" sz="6600" dirty="0"/>
-          </a:p>
-        </p:txBody>
-      </p:sp>
-      <p:sp>
-        <p:nvSpPr>
-          <p:cNvPr id="10" name="Text 8"/>
-          <p:cNvSpPr txBox="1"/>
-          <p:nvPr/>
-        </p:nvSpPr>
-        <p:spPr>
-          <a:xfrm>
-            <a:off x="9006840" y="3474720"/>
-            <a:ext cx="2377440" cy="731520"/>
-          </a:xfrm>
-          <a:prstGeom prst="rect">
-            <a:avLst/>
-          </a:prstGeom>
-          <a:noFill/>
-          <a:ln/>
-        </p:spPr>
-        <p:txBody>
-          <a:bodyPr wrap="square" lIns="0" tIns="0" rIns="0" bIns="0" rtlCol="0" anchor="t"/>
-          <a:lstStyle/>
-          <a:p>
-            <a:pPr indent="0" marL="0">
-              <a:buNone/>
-            </a:pPr>
-            <a:r>
-              <a:rPr lang="en-US" sz="1700" dirty="0">
-                <a:solidFill>
-                  <a:srgbClr val="E6E2D3"/>
+              <a:rPr lang="en-US" sz="1400" dirty="0">
+                <a:solidFill>
+                  <a:srgbClr val="6B6A5C"/>
                 </a:solidFill>
                 <a:latin typeface="Calibri" pitchFamily="34" charset="0"/>
                 <a:ea typeface="Calibri" pitchFamily="34" charset="-122"/>
                 <a:cs typeface="Calibri" pitchFamily="34" charset="-120"/>
               </a:rPr>
-              <a:t>serveur, compte ou abonnement</a:t>
-            </a:r>
-            <a:endParaRPr lang="en-US" sz="1700" dirty="0"/>
-          </a:p>
-        </p:txBody>
-      </p:sp>
-      <p:sp>
-        <p:nvSpPr>
-          <p:cNvPr id="11" name="Text 9"/>
+              <a:t>Fiches et calculateurs disponibles sans réseau, au champ.</a:t>
+            </a:r>
+            <a:endParaRPr lang="en-US" sz="1400" dirty="0"/>
+          </a:p>
+        </p:txBody>
+      </p:sp>
+      <p:sp>
+        <p:nvSpPr>
+          <p:cNvPr id="13" name="Shape 9"/>
+          <p:cNvSpPr/>
+          <p:nvPr/>
+        </p:nvSpPr>
+        <p:spPr>
+          <a:xfrm>
+            <a:off x="8046720" y="1600200"/>
+            <a:ext cx="3429000" cy="2011680"/>
+          </a:xfrm>
+          <a:prstGeom prst="roundRect">
+            <a:avLst>
+              <a:gd name="adj" fmla="val 5455"/>
+            </a:avLst>
+          </a:prstGeom>
+          <a:solidFill>
+            <a:srgbClr val="FFFFFF"/>
+          </a:solidFill>
+          <a:ln w="9525">
+            <a:solidFill>
+              <a:srgbClr val="DCD5C3"/>
+            </a:solidFill>
+            <a:prstDash val="solid"/>
+          </a:ln>
+          <a:effectLst>
+            <a:outerShdw sx="100000" sy="100000" kx="0" ky="0" algn="bl" rotWithShape="0" blurRad="101600" dist="25400" dir="5400000">
+              <a:srgbClr val="000000">
+                <a:alpha val="12000"/>
+              </a:srgbClr>
+            </a:outerShdw>
+          </a:effectLst>
+        </p:spPr>
+      </p:sp>
+      <p:sp>
+        <p:nvSpPr>
+          <p:cNvPr id="14" name="Shape 10"/>
+          <p:cNvSpPr/>
+          <p:nvPr/>
+        </p:nvSpPr>
+        <p:spPr>
+          <a:xfrm>
+            <a:off x="8321040" y="1874520"/>
+            <a:ext cx="640080" cy="640080"/>
+          </a:xfrm>
+          <a:prstGeom prst="ellipse">
+            <a:avLst/>
+          </a:prstGeom>
+          <a:solidFill>
+            <a:srgbClr val="2B3A1F"/>
+          </a:solidFill>
+          <a:ln w="12700">
+            <a:solidFill>
+              <a:srgbClr val="2B3A1F"/>
+            </a:solidFill>
+            <a:prstDash val="solid"/>
+          </a:ln>
+        </p:spPr>
+      </p:sp>
+      <p:pic>
+        <p:nvPicPr>
+          <p:cNvPr id="15" name="Image 2" descr="preencoded.png">    </p:cNvPr>
+          <p:cNvPicPr>
+            <a:picLocks noChangeAspect="1"/>
+          </p:cNvPicPr>
+          <p:nvPr/>
+        </p:nvPicPr>
+        <p:blipFill>
+          <a:blip r:embed="rId3"/>
+          <a:stretch>
+            <a:fillRect/>
+          </a:stretch>
+        </p:blipFill>
+        <p:spPr>
+          <a:xfrm>
+            <a:off x="8481060" y="2034540"/>
+            <a:ext cx="320040" cy="320040"/>
+          </a:xfrm>
+          <a:prstGeom prst="rect">
+            <a:avLst/>
+          </a:prstGeom>
+        </p:spPr>
+      </p:pic>
+      <p:sp>
+        <p:nvSpPr>
+          <p:cNvPr id="16" name="Text 11"/>
           <p:cNvSpPr txBox="1"/>
           <p:nvPr/>
         </p:nvSpPr>
         <p:spPr>
           <a:xfrm>
-            <a:off x="640080" y="5120640"/>
-            <a:ext cx="10881360" cy="457200"/>
+            <a:off x="9098280" y="1920240"/>
+            <a:ext cx="2240280" cy="548640"/>
           </a:xfrm>
           <a:prstGeom prst="rect">
             <a:avLst/>
@@ -8842,17 +8299,539 @@
               <a:buNone/>
             </a:pPr>
             <a:r>
-              <a:rPr lang="en-US" sz="1600" i="1" dirty="0">
-                <a:solidFill>
-                  <a:srgbClr val="A8A48F"/>
+              <a:rPr lang="en-US" sz="1700" b="1" dirty="0">
+                <a:solidFill>
+                  <a:srgbClr val="22261C"/>
                 </a:solidFill>
                 <a:latin typeface="Calibri" pitchFamily="34" charset="0"/>
                 <a:ea typeface="Calibri" pitchFamily="34" charset="-122"/>
                 <a:cs typeface="Calibri" pitchFamily="34" charset="-120"/>
               </a:rPr>
-              <a:t>≈ 180 Ko · fonctionne hors-ligne · ~15 Ko de données par actualisation météo</a:t>
-            </a:r>
-            <a:endParaRPr lang="en-US" sz="1600" dirty="0"/>
+              <a:t>Installable (PWA)</a:t>
+            </a:r>
+            <a:endParaRPr lang="en-US" sz="1700" dirty="0"/>
+          </a:p>
+        </p:txBody>
+      </p:sp>
+      <p:sp>
+        <p:nvSpPr>
+          <p:cNvPr id="17" name="Text 12"/>
+          <p:cNvSpPr txBox="1"/>
+          <p:nvPr/>
+        </p:nvSpPr>
+        <p:spPr>
+          <a:xfrm>
+            <a:off x="8321040" y="2651760"/>
+            <a:ext cx="2926080" cy="822960"/>
+          </a:xfrm>
+          <a:prstGeom prst="rect">
+            <a:avLst/>
+          </a:prstGeom>
+          <a:noFill/>
+          <a:ln/>
+        </p:spPr>
+        <p:txBody>
+          <a:bodyPr wrap="square" lIns="0" tIns="0" rIns="0" bIns="0" rtlCol="0" anchor="t"/>
+          <a:lstStyle/>
+          <a:p>
+            <a:pPr indent="0" marL="0">
+              <a:buNone/>
+            </a:pPr>
+            <a:r>
+              <a:rPr lang="en-US" sz="1400" dirty="0">
+                <a:solidFill>
+                  <a:srgbClr val="6B6A5C"/>
+                </a:solidFill>
+                <a:latin typeface="Calibri" pitchFamily="34" charset="0"/>
+                <a:ea typeface="Calibri" pitchFamily="34" charset="-122"/>
+                <a:cs typeface="Calibri" pitchFamily="34" charset="-120"/>
+              </a:rPr>
+              <a:t>Ajout à l'écran d'accueil, comme une application native.</a:t>
+            </a:r>
+            <a:endParaRPr lang="en-US" sz="1400" dirty="0"/>
+          </a:p>
+        </p:txBody>
+      </p:sp>
+      <p:sp>
+        <p:nvSpPr>
+          <p:cNvPr id="18" name="Shape 13"/>
+          <p:cNvSpPr/>
+          <p:nvPr/>
+        </p:nvSpPr>
+        <p:spPr>
+          <a:xfrm>
+            <a:off x="640080" y="3886200"/>
+            <a:ext cx="3429000" cy="2011680"/>
+          </a:xfrm>
+          <a:prstGeom prst="roundRect">
+            <a:avLst>
+              <a:gd name="adj" fmla="val 5455"/>
+            </a:avLst>
+          </a:prstGeom>
+          <a:solidFill>
+            <a:srgbClr val="FFFFFF"/>
+          </a:solidFill>
+          <a:ln w="9525">
+            <a:solidFill>
+              <a:srgbClr val="DCD5C3"/>
+            </a:solidFill>
+            <a:prstDash val="solid"/>
+          </a:ln>
+          <a:effectLst>
+            <a:outerShdw sx="100000" sy="100000" kx="0" ky="0" algn="bl" rotWithShape="0" blurRad="101600" dist="25400" dir="5400000">
+              <a:srgbClr val="000000">
+                <a:alpha val="12000"/>
+              </a:srgbClr>
+            </a:outerShdw>
+          </a:effectLst>
+        </p:spPr>
+      </p:sp>
+      <p:sp>
+        <p:nvSpPr>
+          <p:cNvPr id="19" name="Shape 14"/>
+          <p:cNvSpPr/>
+          <p:nvPr/>
+        </p:nvSpPr>
+        <p:spPr>
+          <a:xfrm>
+            <a:off x="914400" y="4160520"/>
+            <a:ext cx="640080" cy="640080"/>
+          </a:xfrm>
+          <a:prstGeom prst="ellipse">
+            <a:avLst/>
+          </a:prstGeom>
+          <a:solidFill>
+            <a:srgbClr val="2B3A1F"/>
+          </a:solidFill>
+          <a:ln w="12700">
+            <a:solidFill>
+              <a:srgbClr val="2B3A1F"/>
+            </a:solidFill>
+            <a:prstDash val="solid"/>
+          </a:ln>
+        </p:spPr>
+      </p:sp>
+      <p:pic>
+        <p:nvPicPr>
+          <p:cNvPr id="20" name="Image 3" descr="preencoded.png">    </p:cNvPr>
+          <p:cNvPicPr>
+            <a:picLocks noChangeAspect="1"/>
+          </p:cNvPicPr>
+          <p:nvPr/>
+        </p:nvPicPr>
+        <p:blipFill>
+          <a:blip r:embed="rId4"/>
+          <a:stretch>
+            <a:fillRect/>
+          </a:stretch>
+        </p:blipFill>
+        <p:spPr>
+          <a:xfrm>
+            <a:off x="1074420" y="4320540"/>
+            <a:ext cx="320040" cy="320040"/>
+          </a:xfrm>
+          <a:prstGeom prst="rect">
+            <a:avLst/>
+          </a:prstGeom>
+        </p:spPr>
+      </p:pic>
+      <p:sp>
+        <p:nvSpPr>
+          <p:cNvPr id="21" name="Text 15"/>
+          <p:cNvSpPr txBox="1"/>
+          <p:nvPr/>
+        </p:nvSpPr>
+        <p:spPr>
+          <a:xfrm>
+            <a:off x="1691640" y="4206240"/>
+            <a:ext cx="2240280" cy="548640"/>
+          </a:xfrm>
+          <a:prstGeom prst="rect">
+            <a:avLst/>
+          </a:prstGeom>
+          <a:noFill/>
+          <a:ln/>
+        </p:spPr>
+        <p:txBody>
+          <a:bodyPr wrap="square" lIns="0" tIns="0" rIns="0" bIns="0" rtlCol="0" anchor="ctr"/>
+          <a:lstStyle/>
+          <a:p>
+            <a:pPr indent="0" marL="0">
+              <a:buNone/>
+            </a:pPr>
+            <a:r>
+              <a:rPr lang="en-US" sz="1700" b="1" dirty="0">
+                <a:solidFill>
+                  <a:srgbClr val="22261C"/>
+                </a:solidFill>
+                <a:latin typeface="Calibri" pitchFamily="34" charset="0"/>
+                <a:ea typeface="Calibri" pitchFamily="34" charset="-122"/>
+                <a:cs typeface="Calibri" pitchFamily="34" charset="-120"/>
+              </a:rPr>
+              <a:t>Données privées</a:t>
+            </a:r>
+            <a:endParaRPr lang="en-US" sz="1700" dirty="0"/>
+          </a:p>
+        </p:txBody>
+      </p:sp>
+      <p:sp>
+        <p:nvSpPr>
+          <p:cNvPr id="22" name="Text 16"/>
+          <p:cNvSpPr txBox="1"/>
+          <p:nvPr/>
+        </p:nvSpPr>
+        <p:spPr>
+          <a:xfrm>
+            <a:off x="914400" y="4937760"/>
+            <a:ext cx="2926080" cy="822960"/>
+          </a:xfrm>
+          <a:prstGeom prst="rect">
+            <a:avLst/>
+          </a:prstGeom>
+          <a:noFill/>
+          <a:ln/>
+        </p:spPr>
+        <p:txBody>
+          <a:bodyPr wrap="square" lIns="0" tIns="0" rIns="0" bIns="0" rtlCol="0" anchor="t"/>
+          <a:lstStyle/>
+          <a:p>
+            <a:pPr indent="0" marL="0">
+              <a:buNone/>
+            </a:pPr>
+            <a:r>
+              <a:rPr lang="en-US" sz="1400" dirty="0">
+                <a:solidFill>
+                  <a:srgbClr val="6B6A5C"/>
+                </a:solidFill>
+                <a:latin typeface="Calibri" pitchFamily="34" charset="0"/>
+                <a:ea typeface="Calibri" pitchFamily="34" charset="-122"/>
+                <a:cs typeface="Calibri" pitchFamily="34" charset="-120"/>
+              </a:rPr>
+              <a:t>Position conservée uniquement sur l'appareil (localStorage).</a:t>
+            </a:r>
+            <a:endParaRPr lang="en-US" sz="1400" dirty="0"/>
+          </a:p>
+        </p:txBody>
+      </p:sp>
+      <p:sp>
+        <p:nvSpPr>
+          <p:cNvPr id="23" name="Shape 17"/>
+          <p:cNvSpPr/>
+          <p:nvPr/>
+        </p:nvSpPr>
+        <p:spPr>
+          <a:xfrm>
+            <a:off x="4343400" y="3886200"/>
+            <a:ext cx="3429000" cy="2011680"/>
+          </a:xfrm>
+          <a:prstGeom prst="roundRect">
+            <a:avLst>
+              <a:gd name="adj" fmla="val 5455"/>
+            </a:avLst>
+          </a:prstGeom>
+          <a:solidFill>
+            <a:srgbClr val="FFFFFF"/>
+          </a:solidFill>
+          <a:ln w="9525">
+            <a:solidFill>
+              <a:srgbClr val="DCD5C3"/>
+            </a:solidFill>
+            <a:prstDash val="solid"/>
+          </a:ln>
+          <a:effectLst>
+            <a:outerShdw sx="100000" sy="100000" kx="0" ky="0" algn="bl" rotWithShape="0" blurRad="101600" dist="25400" dir="5400000">
+              <a:srgbClr val="000000">
+                <a:alpha val="12000"/>
+              </a:srgbClr>
+            </a:outerShdw>
+          </a:effectLst>
+        </p:spPr>
+      </p:sp>
+      <p:sp>
+        <p:nvSpPr>
+          <p:cNvPr id="24" name="Shape 18"/>
+          <p:cNvSpPr/>
+          <p:nvPr/>
+        </p:nvSpPr>
+        <p:spPr>
+          <a:xfrm>
+            <a:off x="4617720" y="4160520"/>
+            <a:ext cx="640080" cy="640080"/>
+          </a:xfrm>
+          <a:prstGeom prst="ellipse">
+            <a:avLst/>
+          </a:prstGeom>
+          <a:solidFill>
+            <a:srgbClr val="2B3A1F"/>
+          </a:solidFill>
+          <a:ln w="12700">
+            <a:solidFill>
+              <a:srgbClr val="2B3A1F"/>
+            </a:solidFill>
+            <a:prstDash val="solid"/>
+          </a:ln>
+        </p:spPr>
+      </p:sp>
+      <p:pic>
+        <p:nvPicPr>
+          <p:cNvPr id="25" name="Image 4" descr="preencoded.png">    </p:cNvPr>
+          <p:cNvPicPr>
+            <a:picLocks noChangeAspect="1"/>
+          </p:cNvPicPr>
+          <p:nvPr/>
+        </p:nvPicPr>
+        <p:blipFill>
+          <a:blip r:embed="rId5"/>
+          <a:stretch>
+            <a:fillRect/>
+          </a:stretch>
+        </p:blipFill>
+        <p:spPr>
+          <a:xfrm>
+            <a:off x="4777740" y="4320540"/>
+            <a:ext cx="320040" cy="320040"/>
+          </a:xfrm>
+          <a:prstGeom prst="rect">
+            <a:avLst/>
+          </a:prstGeom>
+        </p:spPr>
+      </p:pic>
+      <p:sp>
+        <p:nvSpPr>
+          <p:cNvPr id="26" name="Text 19"/>
+          <p:cNvSpPr txBox="1"/>
+          <p:nvPr/>
+        </p:nvSpPr>
+        <p:spPr>
+          <a:xfrm>
+            <a:off x="5394960" y="4206240"/>
+            <a:ext cx="2240280" cy="548640"/>
+          </a:xfrm>
+          <a:prstGeom prst="rect">
+            <a:avLst/>
+          </a:prstGeom>
+          <a:noFill/>
+          <a:ln/>
+        </p:spPr>
+        <p:txBody>
+          <a:bodyPr wrap="square" lIns="0" tIns="0" rIns="0" bIns="0" rtlCol="0" anchor="ctr"/>
+          <a:lstStyle/>
+          <a:p>
+            <a:pPr indent="0" marL="0">
+              <a:buNone/>
+            </a:pPr>
+            <a:r>
+              <a:rPr lang="en-US" sz="1700" b="1" dirty="0">
+                <a:solidFill>
+                  <a:srgbClr val="22261C"/>
+                </a:solidFill>
+                <a:latin typeface="Calibri" pitchFamily="34" charset="0"/>
+                <a:ea typeface="Calibri" pitchFamily="34" charset="-122"/>
+                <a:cs typeface="Calibri" pitchFamily="34" charset="-120"/>
+              </a:rPr>
+              <a:t>Faible empreinte</a:t>
+            </a:r>
+            <a:endParaRPr lang="en-US" sz="1700" dirty="0"/>
+          </a:p>
+        </p:txBody>
+      </p:sp>
+      <p:sp>
+        <p:nvSpPr>
+          <p:cNvPr id="27" name="Text 20"/>
+          <p:cNvSpPr txBox="1"/>
+          <p:nvPr/>
+        </p:nvSpPr>
+        <p:spPr>
+          <a:xfrm>
+            <a:off x="4617720" y="4937760"/>
+            <a:ext cx="2926080" cy="822960"/>
+          </a:xfrm>
+          <a:prstGeom prst="rect">
+            <a:avLst/>
+          </a:prstGeom>
+          <a:noFill/>
+          <a:ln/>
+        </p:spPr>
+        <p:txBody>
+          <a:bodyPr wrap="square" lIns="0" tIns="0" rIns="0" bIns="0" rtlCol="0" anchor="t"/>
+          <a:lstStyle/>
+          <a:p>
+            <a:pPr indent="0" marL="0">
+              <a:buNone/>
+            </a:pPr>
+            <a:r>
+              <a:rPr lang="en-US" sz="1400" dirty="0">
+                <a:solidFill>
+                  <a:srgbClr val="6B6A5C"/>
+                </a:solidFill>
+                <a:latin typeface="Calibri" pitchFamily="34" charset="0"/>
+                <a:ea typeface="Calibri" pitchFamily="34" charset="-122"/>
+                <a:cs typeface="Calibri" pitchFamily="34" charset="-120"/>
+              </a:rPr>
+              <a:t>Pas de base de données, requêtes météo minimales.</a:t>
+            </a:r>
+            <a:endParaRPr lang="en-US" sz="1400" dirty="0"/>
+          </a:p>
+        </p:txBody>
+      </p:sp>
+      <p:sp>
+        <p:nvSpPr>
+          <p:cNvPr id="28" name="Shape 21"/>
+          <p:cNvSpPr/>
+          <p:nvPr/>
+        </p:nvSpPr>
+        <p:spPr>
+          <a:xfrm>
+            <a:off x="8046720" y="3886200"/>
+            <a:ext cx="3429000" cy="2011680"/>
+          </a:xfrm>
+          <a:prstGeom prst="roundRect">
+            <a:avLst>
+              <a:gd name="adj" fmla="val 5455"/>
+            </a:avLst>
+          </a:prstGeom>
+          <a:solidFill>
+            <a:srgbClr val="FFFFFF"/>
+          </a:solidFill>
+          <a:ln w="9525">
+            <a:solidFill>
+              <a:srgbClr val="DCD5C3"/>
+            </a:solidFill>
+            <a:prstDash val="solid"/>
+          </a:ln>
+          <a:effectLst>
+            <a:outerShdw sx="100000" sy="100000" kx="0" ky="0" algn="bl" rotWithShape="0" blurRad="101600" dist="25400" dir="5400000">
+              <a:srgbClr val="000000">
+                <a:alpha val="12000"/>
+              </a:srgbClr>
+            </a:outerShdw>
+          </a:effectLst>
+        </p:spPr>
+      </p:sp>
+      <p:sp>
+        <p:nvSpPr>
+          <p:cNvPr id="29" name="Shape 22"/>
+          <p:cNvSpPr/>
+          <p:nvPr/>
+        </p:nvSpPr>
+        <p:spPr>
+          <a:xfrm>
+            <a:off x="8321040" y="4160520"/>
+            <a:ext cx="640080" cy="640080"/>
+          </a:xfrm>
+          <a:prstGeom prst="ellipse">
+            <a:avLst/>
+          </a:prstGeom>
+          <a:solidFill>
+            <a:srgbClr val="2B3A1F"/>
+          </a:solidFill>
+          <a:ln w="12700">
+            <a:solidFill>
+              <a:srgbClr val="2B3A1F"/>
+            </a:solidFill>
+            <a:prstDash val="solid"/>
+          </a:ln>
+        </p:spPr>
+      </p:sp>
+      <p:pic>
+        <p:nvPicPr>
+          <p:cNvPr id="30" name="Image 5" descr="preencoded.png">    </p:cNvPr>
+          <p:cNvPicPr>
+            <a:picLocks noChangeAspect="1"/>
+          </p:cNvPicPr>
+          <p:nvPr/>
+        </p:nvPicPr>
+        <p:blipFill>
+          <a:blip r:embed="rId6"/>
+          <a:stretch>
+            <a:fillRect/>
+          </a:stretch>
+        </p:blipFill>
+        <p:spPr>
+          <a:xfrm>
+            <a:off x="8481060" y="4320540"/>
+            <a:ext cx="320040" cy="320040"/>
+          </a:xfrm>
+          <a:prstGeom prst="rect">
+            <a:avLst/>
+          </a:prstGeom>
+        </p:spPr>
+      </p:pic>
+      <p:sp>
+        <p:nvSpPr>
+          <p:cNvPr id="31" name="Text 23"/>
+          <p:cNvSpPr txBox="1"/>
+          <p:nvPr/>
+        </p:nvSpPr>
+        <p:spPr>
+          <a:xfrm>
+            <a:off x="9098280" y="4206240"/>
+            <a:ext cx="2240280" cy="548640"/>
+          </a:xfrm>
+          <a:prstGeom prst="rect">
+            <a:avLst/>
+          </a:prstGeom>
+          <a:noFill/>
+          <a:ln/>
+        </p:spPr>
+        <p:txBody>
+          <a:bodyPr wrap="square" lIns="0" tIns="0" rIns="0" bIns="0" rtlCol="0" anchor="ctr"/>
+          <a:lstStyle/>
+          <a:p>
+            <a:pPr indent="0" marL="0">
+              <a:buNone/>
+            </a:pPr>
+            <a:r>
+              <a:rPr lang="en-US" sz="1700" b="1" dirty="0">
+                <a:solidFill>
+                  <a:srgbClr val="22261C"/>
+                </a:solidFill>
+                <a:latin typeface="Calibri" pitchFamily="34" charset="0"/>
+                <a:ea typeface="Calibri" pitchFamily="34" charset="-122"/>
+                <a:cs typeface="Calibri" pitchFamily="34" charset="-120"/>
+              </a:rPr>
+              <a:t>Libre (MIT)</a:t>
+            </a:r>
+            <a:endParaRPr lang="en-US" sz="1700" dirty="0"/>
+          </a:p>
+        </p:txBody>
+      </p:sp>
+      <p:sp>
+        <p:nvSpPr>
+          <p:cNvPr id="32" name="Text 24"/>
+          <p:cNvSpPr txBox="1"/>
+          <p:nvPr/>
+        </p:nvSpPr>
+        <p:spPr>
+          <a:xfrm>
+            <a:off x="8321040" y="4937760"/>
+            <a:ext cx="2926080" cy="822960"/>
+          </a:xfrm>
+          <a:prstGeom prst="rect">
+            <a:avLst/>
+          </a:prstGeom>
+          <a:noFill/>
+          <a:ln/>
+        </p:spPr>
+        <p:txBody>
+          <a:bodyPr wrap="square" lIns="0" tIns="0" rIns="0" bIns="0" rtlCol="0" anchor="t"/>
+          <a:lstStyle/>
+          <a:p>
+            <a:pPr indent="0" marL="0">
+              <a:buNone/>
+            </a:pPr>
+            <a:r>
+              <a:rPr lang="en-US" sz="1400" dirty="0">
+                <a:solidFill>
+                  <a:srgbClr val="6B6A5C"/>
+                </a:solidFill>
+                <a:latin typeface="Calibri" pitchFamily="34" charset="0"/>
+                <a:ea typeface="Calibri" pitchFamily="34" charset="-122"/>
+                <a:cs typeface="Calibri" pitchFamily="34" charset="-120"/>
+              </a:rPr>
+              <a:t>Code ouvert, réutilisable par d'autres territoires.</a:t>
+            </a:r>
+            <a:endParaRPr lang="en-US" sz="1400" dirty="0"/>
           </a:p>
         </p:txBody>
       </p:sp>
@@ -8921,7 +8900,7 @@
                 <a:ea typeface="Cambria" pitchFamily="34" charset="-122"/>
                 <a:cs typeface="Cambria" pitchFamily="34" charset="-120"/>
               </a:rPr>
-              <a:t>Sobriété </a:t>
+              <a:t>Sources </a:t>
             </a:r>
             <a:pPr indent="0" marL="0">
               <a:buNone/>
@@ -8935,7 +8914,7 @@
                 <a:ea typeface="Cambria" pitchFamily="34" charset="-122"/>
                 <a:cs typeface="Cambria" pitchFamily="34" charset="-120"/>
               </a:rPr>
-              <a:t>numérique par conception</a:t>
+              <a:t>et limites</a:t>
             </a:r>
             <a:endParaRPr lang="en-US" sz="3600" dirty="0"/>
           </a:p>
@@ -8949,12 +8928,12 @@
         </p:nvSpPr>
         <p:spPr>
           <a:xfrm>
-            <a:off x="640080" y="1600200"/>
-            <a:ext cx="3429000" cy="2011680"/>
+            <a:off x="640080" y="1463040"/>
+            <a:ext cx="5303520" cy="3657600"/>
           </a:xfrm>
           <a:prstGeom prst="roundRect">
             <a:avLst>
-              <a:gd name="adj" fmla="val 5455"/>
+              <a:gd name="adj" fmla="val 3000"/>
             </a:avLst>
           </a:prstGeom>
           <a:solidFill>
@@ -8983,18 +8962,18 @@
         </p:nvSpPr>
         <p:spPr>
           <a:xfrm>
-            <a:off x="914400" y="1874520"/>
+            <a:off x="914400" y="1737360"/>
             <a:ext cx="640080" cy="640080"/>
           </a:xfrm>
           <a:prstGeom prst="ellipse">
             <a:avLst/>
           </a:prstGeom>
           <a:solidFill>
-            <a:srgbClr val="2B3A1F"/>
+            <a:srgbClr val="4A5E2E"/>
           </a:solidFill>
           <a:ln w="12700">
             <a:solidFill>
-              <a:srgbClr val="2B3A1F"/>
+              <a:srgbClr val="4A5E2E"/>
             </a:solidFill>
             <a:prstDash val="solid"/>
           </a:ln>
@@ -9016,7 +8995,7 @@
         </p:blipFill>
         <p:spPr>
           <a:xfrm>
-            <a:off x="1074420" y="2034540"/>
+            <a:off x="1074420" y="1897380"/>
             <a:ext cx="320040" cy="320040"/>
           </a:xfrm>
           <a:prstGeom prst="rect">
@@ -9032,8 +9011,8 @@
         </p:nvSpPr>
         <p:spPr>
           <a:xfrm>
-            <a:off x="1691640" y="1920240"/>
-            <a:ext cx="2240280" cy="548640"/>
+            <a:off x="1737360" y="1783080"/>
+            <a:ext cx="4023360" cy="548640"/>
           </a:xfrm>
           <a:prstGeom prst="rect">
             <a:avLst/>
@@ -9049,7 +9028,49 @@
               <a:buNone/>
             </a:pPr>
             <a:r>
-              <a:rPr lang="en-US" sz="1700" b="1" dirty="0">
+              <a:rPr lang="en-US" sz="2000" b="1" dirty="0">
+                <a:solidFill>
+                  <a:srgbClr val="22261C"/>
+                </a:solidFill>
+                <a:latin typeface="Cambria" pitchFamily="34" charset="0"/>
+                <a:ea typeface="Cambria" pitchFamily="34" charset="-122"/>
+                <a:cs typeface="Cambria" pitchFamily="34" charset="-120"/>
+              </a:rPr>
+              <a:t>Références mobilisées</a:t>
+            </a:r>
+            <a:endParaRPr lang="en-US" sz="2000" dirty="0"/>
+          </a:p>
+        </p:txBody>
+      </p:sp>
+      <p:sp>
+        <p:nvSpPr>
+          <p:cNvPr id="7" name="Text 4"/>
+          <p:cNvSpPr txBox="1"/>
+          <p:nvPr/>
+        </p:nvSpPr>
+        <p:spPr>
+          <a:xfrm>
+            <a:off x="914400" y="2560320"/>
+            <a:ext cx="4754880" cy="3200400"/>
+          </a:xfrm>
+          <a:prstGeom prst="rect">
+            <a:avLst/>
+          </a:prstGeom>
+          <a:noFill/>
+          <a:ln/>
+        </p:spPr>
+        <p:txBody>
+          <a:bodyPr wrap="square" lIns="0" tIns="0" rIns="0" bIns="0" rtlCol="0" anchor="t"/>
+          <a:lstStyle/>
+          <a:p>
+            <a:pPr indent="0" marL="0">
+              <a:spcAft>
+                <a:spcPts val="1000"/>
+              </a:spcAft>
+              <a:buNone/>
+            </a:pPr>
+            <a:r>
+              <a:rPr lang="en-US" sz="1500" b="1" dirty="0">
                 <a:solidFill>
                   <a:srgbClr val="22261C"/>
                 </a:solidFill>
@@ -9057,48 +9078,100 @@
                 <a:ea typeface="Calibri" pitchFamily="34" charset="-122"/>
                 <a:cs typeface="Calibri" pitchFamily="34" charset="-120"/>
               </a:rPr>
-              <a:t>Un seul fichier HTML</a:t>
-            </a:r>
-            <a:endParaRPr lang="en-US" sz="1700" dirty="0"/>
-          </a:p>
-        </p:txBody>
-      </p:sp>
-      <p:sp>
-        <p:nvSpPr>
-          <p:cNvPr id="7" name="Text 4"/>
-          <p:cNvSpPr txBox="1"/>
-          <p:nvPr/>
-        </p:nvSpPr>
-        <p:spPr>
-          <a:xfrm>
-            <a:off x="914400" y="2651760"/>
-            <a:ext cx="2926080" cy="822960"/>
-          </a:xfrm>
-          <a:prstGeom prst="rect">
-            <a:avLst/>
-          </a:prstGeom>
-          <a:noFill/>
-          <a:ln/>
-        </p:spPr>
-        <p:txBody>
-          <a:bodyPr wrap="square" lIns="0" tIns="0" rIns="0" bIns="0" rtlCol="0" anchor="t"/>
-          <a:lstStyle/>
-          <a:p>
+              <a:t>Maraîchage : </a:t>
+            </a:r>
             <a:pPr indent="0" marL="0">
-              <a:buNone/>
-            </a:pPr>
-            <a:r>
-              <a:rPr lang="en-US" sz="1400" dirty="0">
-                <a:solidFill>
-                  <a:srgbClr val="6B6A5C"/>
+              <a:spcAft>
+                <a:spcPts val="1000"/>
+              </a:spcAft>
+              <a:buNone/>
+            </a:pPr>
+            <a:r>
+              <a:rPr lang="en-US" sz="1500" dirty="0">
+                <a:solidFill>
+                  <a:srgbClr val="22261C"/>
                 </a:solidFill>
                 <a:latin typeface="Calibri" pitchFamily="34" charset="0"/>
                 <a:ea typeface="Calibri" pitchFamily="34" charset="-122"/>
                 <a:cs typeface="Calibri" pitchFamily="34" charset="-120"/>
               </a:rPr>
-              <a:t>Application statique, sans build, hébergée gratuitement sur GitHub Pages.</a:t>
-            </a:r>
-            <a:endParaRPr lang="en-US" sz="1400" dirty="0"/>
+              <a:t>AgroBio Bretagne, GRAB, GAB, FNAB, Agrosemens</a:t>
+            </a:r>
+            <a:endParaRPr lang="en-US" sz="1500" dirty="0"/>
+          </a:p>
+          <a:p>
+            <a:pPr indent="0" marL="0">
+              <a:spcAft>
+                <a:spcPts val="1000"/>
+              </a:spcAft>
+              <a:buNone/>
+            </a:pPr>
+            <a:r>
+              <a:rPr lang="en-US" sz="1500" b="1" dirty="0">
+                <a:solidFill>
+                  <a:srgbClr val="22261C"/>
+                </a:solidFill>
+                <a:latin typeface="Calibri" pitchFamily="34" charset="0"/>
+                <a:ea typeface="Calibri" pitchFamily="34" charset="-122"/>
+                <a:cs typeface="Calibri" pitchFamily="34" charset="-120"/>
+              </a:rPr>
+              <a:t>Maladies &amp; climat : </a:t>
+            </a:r>
+            <a:pPr indent="0" marL="0">
+              <a:spcAft>
+                <a:spcPts val="1000"/>
+              </a:spcAft>
+              <a:buNone/>
+            </a:pPr>
+            <a:r>
+              <a:rPr lang="en-US" sz="1500" dirty="0">
+                <a:solidFill>
+                  <a:srgbClr val="22261C"/>
+                </a:solidFill>
+                <a:latin typeface="Calibri" pitchFamily="34" charset="0"/>
+                <a:ea typeface="Calibri" pitchFamily="34" charset="-122"/>
+                <a:cs typeface="Calibri" pitchFamily="34" charset="-120"/>
+              </a:rPr>
+              <a:t>INRAE Ephytia, ITAB, ARVALIS, MAB16 2024, GECO Ecophytopic</a:t>
+            </a:r>
+            <a:endParaRPr lang="en-US" sz="1500" dirty="0"/>
+          </a:p>
+          <a:p>
+            <a:pPr indent="0" marL="0">
+              <a:spcAft>
+                <a:spcPts val="1000"/>
+              </a:spcAft>
+              <a:buNone/>
+            </a:pPr>
+            <a:r>
+              <a:rPr lang="en-US" sz="1500" b="1" dirty="0">
+                <a:solidFill>
+                  <a:srgbClr val="22261C"/>
+                </a:solidFill>
+                <a:latin typeface="Calibri" pitchFamily="34" charset="0"/>
+                <a:ea typeface="Calibri" pitchFamily="34" charset="-122"/>
+                <a:cs typeface="Calibri" pitchFamily="34" charset="-120"/>
+              </a:rPr>
+              <a:t>Météo : </a:t>
+            </a:r>
+            <a:pPr indent="0" marL="0">
+              <a:spcAft>
+                <a:spcPts val="1000"/>
+              </a:spcAft>
+              <a:buNone/>
+            </a:pPr>
+            <a:r>
+              <a:rPr lang="en-US" sz="1500" dirty="0">
+                <a:solidFill>
+                  <a:srgbClr val="22261C"/>
+                </a:solidFill>
+                <a:latin typeface="Calibri" pitchFamily="34" charset="0"/>
+                <a:ea typeface="Calibri" pitchFamily="34" charset="-122"/>
+                <a:cs typeface="Calibri" pitchFamily="34" charset="-120"/>
+              </a:rPr>
+              <a:t>Open-Meteo (gratuit, sans clé API)</a:t>
+            </a:r>
+            <a:endParaRPr lang="en-US" sz="1500" dirty="0"/>
           </a:p>
         </p:txBody>
       </p:sp>
@@ -9110,12 +9183,12 @@
         </p:nvSpPr>
         <p:spPr>
           <a:xfrm>
-            <a:off x="4343400" y="1600200"/>
-            <a:ext cx="3429000" cy="2011680"/>
+            <a:off x="6263640" y="1463040"/>
+            <a:ext cx="5303520" cy="3657600"/>
           </a:xfrm>
           <a:prstGeom prst="roundRect">
             <a:avLst>
-              <a:gd name="adj" fmla="val 5455"/>
+              <a:gd name="adj" fmla="val 3000"/>
             </a:avLst>
           </a:prstGeom>
           <a:solidFill>
@@ -9144,18 +9217,18 @@
         </p:nvSpPr>
         <p:spPr>
           <a:xfrm>
-            <a:off x="4617720" y="1874520"/>
+            <a:off x="6537960" y="1737360"/>
             <a:ext cx="640080" cy="640080"/>
           </a:xfrm>
           <a:prstGeom prst="ellipse">
             <a:avLst/>
           </a:prstGeom>
           <a:solidFill>
-            <a:srgbClr val="2B3A1F"/>
+            <a:srgbClr val="A0472A"/>
           </a:solidFill>
           <a:ln w="12700">
             <a:solidFill>
-              <a:srgbClr val="2B3A1F"/>
+              <a:srgbClr val="A0472A"/>
             </a:solidFill>
             <a:prstDash val="solid"/>
           </a:ln>
@@ -9177,7 +9250,7 @@
         </p:blipFill>
         <p:spPr>
           <a:xfrm>
-            <a:off x="4777740" y="2034540"/>
+            <a:off x="6697980" y="1897380"/>
             <a:ext cx="320040" cy="320040"/>
           </a:xfrm>
           <a:prstGeom prst="rect">
@@ -9193,8 +9266,8 @@
         </p:nvSpPr>
         <p:spPr>
           <a:xfrm>
-            <a:off x="5394960" y="1920240"/>
-            <a:ext cx="2240280" cy="548640"/>
+            <a:off x="7360920" y="1783080"/>
+            <a:ext cx="4023360" cy="548640"/>
           </a:xfrm>
           <a:prstGeom prst="rect">
             <a:avLst/>
@@ -9210,7 +9283,50 @@
               <a:buNone/>
             </a:pPr>
             <a:r>
-              <a:rPr lang="en-US" sz="1700" b="1" dirty="0">
+              <a:rPr lang="en-US" sz="2000" b="1" dirty="0">
+                <a:solidFill>
+                  <a:srgbClr val="22261C"/>
+                </a:solidFill>
+                <a:latin typeface="Cambria" pitchFamily="34" charset="0"/>
+                <a:ea typeface="Cambria" pitchFamily="34" charset="-122"/>
+                <a:cs typeface="Cambria" pitchFamily="34" charset="-120"/>
+              </a:rPr>
+              <a:t>Limites connues</a:t>
+            </a:r>
+            <a:endParaRPr lang="en-US" sz="2000" dirty="0"/>
+          </a:p>
+        </p:txBody>
+      </p:sp>
+      <p:sp>
+        <p:nvSpPr>
+          <p:cNvPr id="12" name="Text 8"/>
+          <p:cNvSpPr txBox="1"/>
+          <p:nvPr/>
+        </p:nvSpPr>
+        <p:spPr>
+          <a:xfrm>
+            <a:off x="6537960" y="2560320"/>
+            <a:ext cx="4754880" cy="3200400"/>
+          </a:xfrm>
+          <a:prstGeom prst="rect">
+            <a:avLst/>
+          </a:prstGeom>
+          <a:noFill/>
+          <a:ln/>
+        </p:spPr>
+        <p:txBody>
+          <a:bodyPr wrap="square" lIns="0" tIns="0" rIns="0" bIns="0" rtlCol="0" anchor="t"/>
+          <a:lstStyle/>
+          <a:p>
+            <a:pPr marL="342900" indent="-342900">
+              <a:spcAft>
+                <a:spcPts val="1000"/>
+              </a:spcAft>
+              <a:buSzPct val="100000"/>
+              <a:buChar char="•"/>
+            </a:pPr>
+            <a:r>
+              <a:rPr lang="en-US" sz="1500" dirty="0">
                 <a:solidFill>
                   <a:srgbClr val="22261C"/>
                 </a:solidFill>
@@ -9218,160 +9334,41 @@
                 <a:ea typeface="Calibri" pitchFamily="34" charset="-122"/>
                 <a:cs typeface="Calibri" pitchFamily="34" charset="-120"/>
               </a:rPr>
-              <a:t>Hors-ligne</a:t>
-            </a:r>
-            <a:endParaRPr lang="en-US" sz="1700" dirty="0"/>
-          </a:p>
-        </p:txBody>
-      </p:sp>
-      <p:sp>
-        <p:nvSpPr>
-          <p:cNvPr id="12" name="Text 8"/>
-          <p:cNvSpPr txBox="1"/>
-          <p:nvPr/>
-        </p:nvSpPr>
-        <p:spPr>
-          <a:xfrm>
-            <a:off x="4617720" y="2651760"/>
-            <a:ext cx="2926080" cy="822960"/>
-          </a:xfrm>
-          <a:prstGeom prst="rect">
-            <a:avLst/>
-          </a:prstGeom>
-          <a:noFill/>
-          <a:ln/>
-        </p:spPr>
-        <p:txBody>
-          <a:bodyPr wrap="square" lIns="0" tIns="0" rIns="0" bIns="0" rtlCol="0" anchor="t"/>
-          <a:lstStyle/>
-          <a:p>
-            <a:pPr indent="0" marL="0">
-              <a:buNone/>
-            </a:pPr>
-            <a:r>
-              <a:rPr lang="en-US" sz="1400" dirty="0">
-                <a:solidFill>
-                  <a:srgbClr val="6B6A5C"/>
+              <a:t>Humidité mesurée à 2 m, pas au feuillage : humectation estimée, non mesurée</a:t>
+            </a:r>
+            <a:endParaRPr lang="en-US" sz="1500" dirty="0"/>
+          </a:p>
+          <a:p>
+            <a:pPr marL="342900" indent="-342900">
+              <a:spcAft>
+                <a:spcPts val="1000"/>
+              </a:spcAft>
+              <a:buSzPct val="100000"/>
+              <a:buChar char="•"/>
+            </a:pPr>
+            <a:r>
+              <a:rPr lang="en-US" sz="1500" dirty="0">
+                <a:solidFill>
+                  <a:srgbClr val="22261C"/>
                 </a:solidFill>
                 <a:latin typeface="Calibri" pitchFamily="34" charset="0"/>
                 <a:ea typeface="Calibri" pitchFamily="34" charset="-122"/>
                 <a:cs typeface="Calibri" pitchFamily="34" charset="-120"/>
               </a:rPr>
-              <a:t>Fiches et calculateurs disponibles sans réseau, au champ.</a:t>
-            </a:r>
-            <a:endParaRPr lang="en-US" sz="1400" dirty="0"/>
-          </a:p>
-        </p:txBody>
-      </p:sp>
-      <p:sp>
-        <p:nvSpPr>
-          <p:cNvPr id="13" name="Shape 9"/>
-          <p:cNvSpPr/>
-          <p:nvPr/>
-        </p:nvSpPr>
-        <p:spPr>
-          <a:xfrm>
-            <a:off x="8046720" y="1600200"/>
-            <a:ext cx="3429000" cy="2011680"/>
-          </a:xfrm>
-          <a:prstGeom prst="roundRect">
-            <a:avLst>
-              <a:gd name="adj" fmla="val 5455"/>
-            </a:avLst>
-          </a:prstGeom>
-          <a:solidFill>
-            <a:srgbClr val="FFFFFF"/>
-          </a:solidFill>
-          <a:ln w="9525">
-            <a:solidFill>
-              <a:srgbClr val="DCD5C3"/>
-            </a:solidFill>
-            <a:prstDash val="solid"/>
-          </a:ln>
-          <a:effectLst>
-            <a:outerShdw sx="100000" sy="100000" kx="0" ky="0" algn="bl" rotWithShape="0" blurRad="101600" dist="25400" dir="5400000">
-              <a:srgbClr val="000000">
-                <a:alpha val="12000"/>
-              </a:srgbClr>
-            </a:outerShdw>
-          </a:effectLst>
-        </p:spPr>
-      </p:sp>
-      <p:sp>
-        <p:nvSpPr>
-          <p:cNvPr id="14" name="Shape 10"/>
-          <p:cNvSpPr/>
-          <p:nvPr/>
-        </p:nvSpPr>
-        <p:spPr>
-          <a:xfrm>
-            <a:off x="8321040" y="1874520"/>
-            <a:ext cx="640080" cy="640080"/>
-          </a:xfrm>
-          <a:prstGeom prst="ellipse">
-            <a:avLst/>
-          </a:prstGeom>
-          <a:solidFill>
-            <a:srgbClr val="2B3A1F"/>
-          </a:solidFill>
-          <a:ln w="12700">
-            <a:solidFill>
-              <a:srgbClr val="2B3A1F"/>
-            </a:solidFill>
-            <a:prstDash val="solid"/>
-          </a:ln>
-        </p:spPr>
-      </p:sp>
-      <p:pic>
-        <p:nvPicPr>
-          <p:cNvPr id="15" name="Image 2" descr="preencoded.png">    </p:cNvPr>
-          <p:cNvPicPr>
-            <a:picLocks noChangeAspect="1"/>
-          </p:cNvPicPr>
-          <p:nvPr/>
-        </p:nvPicPr>
-        <p:blipFill>
-          <a:blip r:embed="rId3"/>
-          <a:stretch>
-            <a:fillRect/>
-          </a:stretch>
-        </p:blipFill>
-        <p:spPr>
-          <a:xfrm>
-            <a:off x="8481060" y="2034540"/>
-            <a:ext cx="320040" cy="320040"/>
-          </a:xfrm>
-          <a:prstGeom prst="rect">
-            <a:avLst/>
-          </a:prstGeom>
-        </p:spPr>
-      </p:pic>
-      <p:sp>
-        <p:nvSpPr>
-          <p:cNvPr id="16" name="Text 11"/>
-          <p:cNvSpPr txBox="1"/>
-          <p:nvPr/>
-        </p:nvSpPr>
-        <p:spPr>
-          <a:xfrm>
-            <a:off x="9098280" y="1920240"/>
-            <a:ext cx="2240280" cy="548640"/>
-          </a:xfrm>
-          <a:prstGeom prst="rect">
-            <a:avLst/>
-          </a:prstGeom>
-          <a:noFill/>
-          <a:ln/>
-        </p:spPr>
-        <p:txBody>
-          <a:bodyPr wrap="square" lIns="0" tIns="0" rIns="0" bIns="0" rtlCol="0" anchor="ctr"/>
-          <a:lstStyle/>
-          <a:p>
-            <a:pPr indent="0" marL="0">
-              <a:buNone/>
-            </a:pPr>
-            <a:r>
-              <a:rPr lang="en-US" sz="1700" b="1" dirty="0">
+              <a:t>Virus (CMV, TSWV, TMV…) sans seuils climatiques : pas d'alerte automatique</a:t>
+            </a:r>
+            <a:endParaRPr lang="en-US" sz="1500" dirty="0"/>
+          </a:p>
+          <a:p>
+            <a:pPr marL="342900" indent="-342900">
+              <a:spcAft>
+                <a:spcPts val="1000"/>
+              </a:spcAft>
+              <a:buSzPct val="100000"/>
+              <a:buChar char="•"/>
+            </a:pPr>
+            <a:r>
+              <a:rPr lang="en-US" sz="1500" dirty="0">
                 <a:solidFill>
                   <a:srgbClr val="22261C"/>
                 </a:solidFill>
@@ -9379,531 +9376,9 @@
                 <a:ea typeface="Calibri" pitchFamily="34" charset="-122"/>
                 <a:cs typeface="Calibri" pitchFamily="34" charset="-120"/>
               </a:rPr>
-              <a:t>Installable (PWA)</a:t>
-            </a:r>
-            <a:endParaRPr lang="en-US" sz="1700" dirty="0"/>
-          </a:p>
-        </p:txBody>
-      </p:sp>
-      <p:sp>
-        <p:nvSpPr>
-          <p:cNvPr id="17" name="Text 12"/>
-          <p:cNvSpPr txBox="1"/>
-          <p:nvPr/>
-        </p:nvSpPr>
-        <p:spPr>
-          <a:xfrm>
-            <a:off x="8321040" y="2651760"/>
-            <a:ext cx="2926080" cy="822960"/>
-          </a:xfrm>
-          <a:prstGeom prst="rect">
-            <a:avLst/>
-          </a:prstGeom>
-          <a:noFill/>
-          <a:ln/>
-        </p:spPr>
-        <p:txBody>
-          <a:bodyPr wrap="square" lIns="0" tIns="0" rIns="0" bIns="0" rtlCol="0" anchor="t"/>
-          <a:lstStyle/>
-          <a:p>
-            <a:pPr indent="0" marL="0">
-              <a:buNone/>
-            </a:pPr>
-            <a:r>
-              <a:rPr lang="en-US" sz="1400" dirty="0">
-                <a:solidFill>
-                  <a:srgbClr val="6B6A5C"/>
-                </a:solidFill>
-                <a:latin typeface="Calibri" pitchFamily="34" charset="0"/>
-                <a:ea typeface="Calibri" pitchFamily="34" charset="-122"/>
-                <a:cs typeface="Calibri" pitchFamily="34" charset="-120"/>
-              </a:rPr>
-              <a:t>Ajout à l'écran d'accueil, comme une application native.</a:t>
-            </a:r>
-            <a:endParaRPr lang="en-US" sz="1400" dirty="0"/>
-          </a:p>
-        </p:txBody>
-      </p:sp>
-      <p:sp>
-        <p:nvSpPr>
-          <p:cNvPr id="18" name="Shape 13"/>
-          <p:cNvSpPr/>
-          <p:nvPr/>
-        </p:nvSpPr>
-        <p:spPr>
-          <a:xfrm>
-            <a:off x="640080" y="3886200"/>
-            <a:ext cx="3429000" cy="2011680"/>
-          </a:xfrm>
-          <a:prstGeom prst="roundRect">
-            <a:avLst>
-              <a:gd name="adj" fmla="val 5455"/>
-            </a:avLst>
-          </a:prstGeom>
-          <a:solidFill>
-            <a:srgbClr val="FFFFFF"/>
-          </a:solidFill>
-          <a:ln w="9525">
-            <a:solidFill>
-              <a:srgbClr val="DCD5C3"/>
-            </a:solidFill>
-            <a:prstDash val="solid"/>
-          </a:ln>
-          <a:effectLst>
-            <a:outerShdw sx="100000" sy="100000" kx="0" ky="0" algn="bl" rotWithShape="0" blurRad="101600" dist="25400" dir="5400000">
-              <a:srgbClr val="000000">
-                <a:alpha val="12000"/>
-              </a:srgbClr>
-            </a:outerShdw>
-          </a:effectLst>
-        </p:spPr>
-      </p:sp>
-      <p:sp>
-        <p:nvSpPr>
-          <p:cNvPr id="19" name="Shape 14"/>
-          <p:cNvSpPr/>
-          <p:nvPr/>
-        </p:nvSpPr>
-        <p:spPr>
-          <a:xfrm>
-            <a:off x="914400" y="4160520"/>
-            <a:ext cx="640080" cy="640080"/>
-          </a:xfrm>
-          <a:prstGeom prst="ellipse">
-            <a:avLst/>
-          </a:prstGeom>
-          <a:solidFill>
-            <a:srgbClr val="2B3A1F"/>
-          </a:solidFill>
-          <a:ln w="12700">
-            <a:solidFill>
-              <a:srgbClr val="2B3A1F"/>
-            </a:solidFill>
-            <a:prstDash val="solid"/>
-          </a:ln>
-        </p:spPr>
-      </p:sp>
-      <p:pic>
-        <p:nvPicPr>
-          <p:cNvPr id="20" name="Image 3" descr="preencoded.png">    </p:cNvPr>
-          <p:cNvPicPr>
-            <a:picLocks noChangeAspect="1"/>
-          </p:cNvPicPr>
-          <p:nvPr/>
-        </p:nvPicPr>
-        <p:blipFill>
-          <a:blip r:embed="rId4"/>
-          <a:stretch>
-            <a:fillRect/>
-          </a:stretch>
-        </p:blipFill>
-        <p:spPr>
-          <a:xfrm>
-            <a:off x="1074420" y="4320540"/>
-            <a:ext cx="320040" cy="320040"/>
-          </a:xfrm>
-          <a:prstGeom prst="rect">
-            <a:avLst/>
-          </a:prstGeom>
-        </p:spPr>
-      </p:pic>
-      <p:sp>
-        <p:nvSpPr>
-          <p:cNvPr id="21" name="Text 15"/>
-          <p:cNvSpPr txBox="1"/>
-          <p:nvPr/>
-        </p:nvSpPr>
-        <p:spPr>
-          <a:xfrm>
-            <a:off x="1691640" y="4206240"/>
-            <a:ext cx="2240280" cy="548640"/>
-          </a:xfrm>
-          <a:prstGeom prst="rect">
-            <a:avLst/>
-          </a:prstGeom>
-          <a:noFill/>
-          <a:ln/>
-        </p:spPr>
-        <p:txBody>
-          <a:bodyPr wrap="square" lIns="0" tIns="0" rIns="0" bIns="0" rtlCol="0" anchor="ctr"/>
-          <a:lstStyle/>
-          <a:p>
-            <a:pPr indent="0" marL="0">
-              <a:buNone/>
-            </a:pPr>
-            <a:r>
-              <a:rPr lang="en-US" sz="1700" b="1" dirty="0">
-                <a:solidFill>
-                  <a:srgbClr val="22261C"/>
-                </a:solidFill>
-                <a:latin typeface="Calibri" pitchFamily="34" charset="0"/>
-                <a:ea typeface="Calibri" pitchFamily="34" charset="-122"/>
-                <a:cs typeface="Calibri" pitchFamily="34" charset="-120"/>
-              </a:rPr>
-              <a:t>Données privées</a:t>
-            </a:r>
-            <a:endParaRPr lang="en-US" sz="1700" dirty="0"/>
-          </a:p>
-        </p:txBody>
-      </p:sp>
-      <p:sp>
-        <p:nvSpPr>
-          <p:cNvPr id="22" name="Text 16"/>
-          <p:cNvSpPr txBox="1"/>
-          <p:nvPr/>
-        </p:nvSpPr>
-        <p:spPr>
-          <a:xfrm>
-            <a:off x="914400" y="4937760"/>
-            <a:ext cx="2926080" cy="822960"/>
-          </a:xfrm>
-          <a:prstGeom prst="rect">
-            <a:avLst/>
-          </a:prstGeom>
-          <a:noFill/>
-          <a:ln/>
-        </p:spPr>
-        <p:txBody>
-          <a:bodyPr wrap="square" lIns="0" tIns="0" rIns="0" bIns="0" rtlCol="0" anchor="t"/>
-          <a:lstStyle/>
-          <a:p>
-            <a:pPr indent="0" marL="0">
-              <a:buNone/>
-            </a:pPr>
-            <a:r>
-              <a:rPr lang="en-US" sz="1400" dirty="0">
-                <a:solidFill>
-                  <a:srgbClr val="6B6A5C"/>
-                </a:solidFill>
-                <a:latin typeface="Calibri" pitchFamily="34" charset="0"/>
-                <a:ea typeface="Calibri" pitchFamily="34" charset="-122"/>
-                <a:cs typeface="Calibri" pitchFamily="34" charset="-120"/>
-              </a:rPr>
-              <a:t>Position conservée uniquement sur l'appareil (localStorage).</a:t>
-            </a:r>
-            <a:endParaRPr lang="en-US" sz="1400" dirty="0"/>
-          </a:p>
-        </p:txBody>
-      </p:sp>
-      <p:sp>
-        <p:nvSpPr>
-          <p:cNvPr id="23" name="Shape 17"/>
-          <p:cNvSpPr/>
-          <p:nvPr/>
-        </p:nvSpPr>
-        <p:spPr>
-          <a:xfrm>
-            <a:off x="4343400" y="3886200"/>
-            <a:ext cx="3429000" cy="2011680"/>
-          </a:xfrm>
-          <a:prstGeom prst="roundRect">
-            <a:avLst>
-              <a:gd name="adj" fmla="val 5455"/>
-            </a:avLst>
-          </a:prstGeom>
-          <a:solidFill>
-            <a:srgbClr val="FFFFFF"/>
-          </a:solidFill>
-          <a:ln w="9525">
-            <a:solidFill>
-              <a:srgbClr val="DCD5C3"/>
-            </a:solidFill>
-            <a:prstDash val="solid"/>
-          </a:ln>
-          <a:effectLst>
-            <a:outerShdw sx="100000" sy="100000" kx="0" ky="0" algn="bl" rotWithShape="0" blurRad="101600" dist="25400" dir="5400000">
-              <a:srgbClr val="000000">
-                <a:alpha val="12000"/>
-              </a:srgbClr>
-            </a:outerShdw>
-          </a:effectLst>
-        </p:spPr>
-      </p:sp>
-      <p:sp>
-        <p:nvSpPr>
-          <p:cNvPr id="24" name="Shape 18"/>
-          <p:cNvSpPr/>
-          <p:nvPr/>
-        </p:nvSpPr>
-        <p:spPr>
-          <a:xfrm>
-            <a:off x="4617720" y="4160520"/>
-            <a:ext cx="640080" cy="640080"/>
-          </a:xfrm>
-          <a:prstGeom prst="ellipse">
-            <a:avLst/>
-          </a:prstGeom>
-          <a:solidFill>
-            <a:srgbClr val="2B3A1F"/>
-          </a:solidFill>
-          <a:ln w="12700">
-            <a:solidFill>
-              <a:srgbClr val="2B3A1F"/>
-            </a:solidFill>
-            <a:prstDash val="solid"/>
-          </a:ln>
-        </p:spPr>
-      </p:sp>
-      <p:pic>
-        <p:nvPicPr>
-          <p:cNvPr id="25" name="Image 4" descr="preencoded.png">    </p:cNvPr>
-          <p:cNvPicPr>
-            <a:picLocks noChangeAspect="1"/>
-          </p:cNvPicPr>
-          <p:nvPr/>
-        </p:nvPicPr>
-        <p:blipFill>
-          <a:blip r:embed="rId5"/>
-          <a:stretch>
-            <a:fillRect/>
-          </a:stretch>
-        </p:blipFill>
-        <p:spPr>
-          <a:xfrm>
-            <a:off x="4777740" y="4320540"/>
-            <a:ext cx="320040" cy="320040"/>
-          </a:xfrm>
-          <a:prstGeom prst="rect">
-            <a:avLst/>
-          </a:prstGeom>
-        </p:spPr>
-      </p:pic>
-      <p:sp>
-        <p:nvSpPr>
-          <p:cNvPr id="26" name="Text 19"/>
-          <p:cNvSpPr txBox="1"/>
-          <p:nvPr/>
-        </p:nvSpPr>
-        <p:spPr>
-          <a:xfrm>
-            <a:off x="5394960" y="4206240"/>
-            <a:ext cx="2240280" cy="548640"/>
-          </a:xfrm>
-          <a:prstGeom prst="rect">
-            <a:avLst/>
-          </a:prstGeom>
-          <a:noFill/>
-          <a:ln/>
-        </p:spPr>
-        <p:txBody>
-          <a:bodyPr wrap="square" lIns="0" tIns="0" rIns="0" bIns="0" rtlCol="0" anchor="ctr"/>
-          <a:lstStyle/>
-          <a:p>
-            <a:pPr indent="0" marL="0">
-              <a:buNone/>
-            </a:pPr>
-            <a:r>
-              <a:rPr lang="en-US" sz="1700" b="1" dirty="0">
-                <a:solidFill>
-                  <a:srgbClr val="22261C"/>
-                </a:solidFill>
-                <a:latin typeface="Calibri" pitchFamily="34" charset="0"/>
-                <a:ea typeface="Calibri" pitchFamily="34" charset="-122"/>
-                <a:cs typeface="Calibri" pitchFamily="34" charset="-120"/>
-              </a:rPr>
-              <a:t>Faible empreinte</a:t>
-            </a:r>
-            <a:endParaRPr lang="en-US" sz="1700" dirty="0"/>
-          </a:p>
-        </p:txBody>
-      </p:sp>
-      <p:sp>
-        <p:nvSpPr>
-          <p:cNvPr id="27" name="Text 20"/>
-          <p:cNvSpPr txBox="1"/>
-          <p:nvPr/>
-        </p:nvSpPr>
-        <p:spPr>
-          <a:xfrm>
-            <a:off x="4617720" y="4937760"/>
-            <a:ext cx="2926080" cy="822960"/>
-          </a:xfrm>
-          <a:prstGeom prst="rect">
-            <a:avLst/>
-          </a:prstGeom>
-          <a:noFill/>
-          <a:ln/>
-        </p:spPr>
-        <p:txBody>
-          <a:bodyPr wrap="square" lIns="0" tIns="0" rIns="0" bIns="0" rtlCol="0" anchor="t"/>
-          <a:lstStyle/>
-          <a:p>
-            <a:pPr indent="0" marL="0">
-              <a:buNone/>
-            </a:pPr>
-            <a:r>
-              <a:rPr lang="en-US" sz="1400" dirty="0">
-                <a:solidFill>
-                  <a:srgbClr val="6B6A5C"/>
-                </a:solidFill>
-                <a:latin typeface="Calibri" pitchFamily="34" charset="0"/>
-                <a:ea typeface="Calibri" pitchFamily="34" charset="-122"/>
-                <a:cs typeface="Calibri" pitchFamily="34" charset="-120"/>
-              </a:rPr>
-              <a:t>Pas de base de données, requêtes météo minimales.</a:t>
-            </a:r>
-            <a:endParaRPr lang="en-US" sz="1400" dirty="0"/>
-          </a:p>
-        </p:txBody>
-      </p:sp>
-      <p:sp>
-        <p:nvSpPr>
-          <p:cNvPr id="28" name="Shape 21"/>
-          <p:cNvSpPr/>
-          <p:nvPr/>
-        </p:nvSpPr>
-        <p:spPr>
-          <a:xfrm>
-            <a:off x="8046720" y="3886200"/>
-            <a:ext cx="3429000" cy="2011680"/>
-          </a:xfrm>
-          <a:prstGeom prst="roundRect">
-            <a:avLst>
-              <a:gd name="adj" fmla="val 5455"/>
-            </a:avLst>
-          </a:prstGeom>
-          <a:solidFill>
-            <a:srgbClr val="FFFFFF"/>
-          </a:solidFill>
-          <a:ln w="9525">
-            <a:solidFill>
-              <a:srgbClr val="DCD5C3"/>
-            </a:solidFill>
-            <a:prstDash val="solid"/>
-          </a:ln>
-          <a:effectLst>
-            <a:outerShdw sx="100000" sy="100000" kx="0" ky="0" algn="bl" rotWithShape="0" blurRad="101600" dist="25400" dir="5400000">
-              <a:srgbClr val="000000">
-                <a:alpha val="12000"/>
-              </a:srgbClr>
-            </a:outerShdw>
-          </a:effectLst>
-        </p:spPr>
-      </p:sp>
-      <p:sp>
-        <p:nvSpPr>
-          <p:cNvPr id="29" name="Shape 22"/>
-          <p:cNvSpPr/>
-          <p:nvPr/>
-        </p:nvSpPr>
-        <p:spPr>
-          <a:xfrm>
-            <a:off x="8321040" y="4160520"/>
-            <a:ext cx="640080" cy="640080"/>
-          </a:xfrm>
-          <a:prstGeom prst="ellipse">
-            <a:avLst/>
-          </a:prstGeom>
-          <a:solidFill>
-            <a:srgbClr val="2B3A1F"/>
-          </a:solidFill>
-          <a:ln w="12700">
-            <a:solidFill>
-              <a:srgbClr val="2B3A1F"/>
-            </a:solidFill>
-            <a:prstDash val="solid"/>
-          </a:ln>
-        </p:spPr>
-      </p:sp>
-      <p:pic>
-        <p:nvPicPr>
-          <p:cNvPr id="30" name="Image 5" descr="preencoded.png">    </p:cNvPr>
-          <p:cNvPicPr>
-            <a:picLocks noChangeAspect="1"/>
-          </p:cNvPicPr>
-          <p:nvPr/>
-        </p:nvPicPr>
-        <p:blipFill>
-          <a:blip r:embed="rId6"/>
-          <a:stretch>
-            <a:fillRect/>
-          </a:stretch>
-        </p:blipFill>
-        <p:spPr>
-          <a:xfrm>
-            <a:off x="8481060" y="4320540"/>
-            <a:ext cx="320040" cy="320040"/>
-          </a:xfrm>
-          <a:prstGeom prst="rect">
-            <a:avLst/>
-          </a:prstGeom>
-        </p:spPr>
-      </p:pic>
-      <p:sp>
-        <p:nvSpPr>
-          <p:cNvPr id="31" name="Text 23"/>
-          <p:cNvSpPr txBox="1"/>
-          <p:nvPr/>
-        </p:nvSpPr>
-        <p:spPr>
-          <a:xfrm>
-            <a:off x="9098280" y="4206240"/>
-            <a:ext cx="2240280" cy="548640"/>
-          </a:xfrm>
-          <a:prstGeom prst="rect">
-            <a:avLst/>
-          </a:prstGeom>
-          <a:noFill/>
-          <a:ln/>
-        </p:spPr>
-        <p:txBody>
-          <a:bodyPr wrap="square" lIns="0" tIns="0" rIns="0" bIns="0" rtlCol="0" anchor="ctr"/>
-          <a:lstStyle/>
-          <a:p>
-            <a:pPr indent="0" marL="0">
-              <a:buNone/>
-            </a:pPr>
-            <a:r>
-              <a:rPr lang="en-US" sz="1700" b="1" dirty="0">
-                <a:solidFill>
-                  <a:srgbClr val="22261C"/>
-                </a:solidFill>
-                <a:latin typeface="Calibri" pitchFamily="34" charset="0"/>
-                <a:ea typeface="Calibri" pitchFamily="34" charset="-122"/>
-                <a:cs typeface="Calibri" pitchFamily="34" charset="-120"/>
-              </a:rPr>
-              <a:t>Libre (MIT)</a:t>
-            </a:r>
-            <a:endParaRPr lang="en-US" sz="1700" dirty="0"/>
-          </a:p>
-        </p:txBody>
-      </p:sp>
-      <p:sp>
-        <p:nvSpPr>
-          <p:cNvPr id="32" name="Text 24"/>
-          <p:cNvSpPr txBox="1"/>
-          <p:nvPr/>
-        </p:nvSpPr>
-        <p:spPr>
-          <a:xfrm>
-            <a:off x="8321040" y="4937760"/>
-            <a:ext cx="2926080" cy="822960"/>
-          </a:xfrm>
-          <a:prstGeom prst="rect">
-            <a:avLst/>
-          </a:prstGeom>
-          <a:noFill/>
-          <a:ln/>
-        </p:spPr>
-        <p:txBody>
-          <a:bodyPr wrap="square" lIns="0" tIns="0" rIns="0" bIns="0" rtlCol="0" anchor="t"/>
-          <a:lstStyle/>
-          <a:p>
-            <a:pPr indent="0" marL="0">
-              <a:buNone/>
-            </a:pPr>
-            <a:r>
-              <a:rPr lang="en-US" sz="1400" dirty="0">
-                <a:solidFill>
-                  <a:srgbClr val="6B6A5C"/>
-                </a:solidFill>
-                <a:latin typeface="Calibri" pitchFamily="34" charset="0"/>
-                <a:ea typeface="Calibri" pitchFamily="34" charset="-122"/>
-                <a:cs typeface="Calibri" pitchFamily="34" charset="-120"/>
-              </a:rPr>
-              <a:t>Code ouvert, réutilisable par d'autres territoires.</a:t>
-            </a:r>
-            <a:endParaRPr lang="en-US" sz="1400" dirty="0"/>
+              <a:t>Seuils volontairement prudents : aide à la décision, pas prescription</a:t>
+            </a:r>
+            <a:endParaRPr lang="en-US" sz="1500" dirty="0"/>
           </a:p>
         </p:txBody>
       </p:sp>

</xml_diff>

<commit_message>
docs(presentation): lien et QR code d'installation sur la diapo de titre
Co-Authored-By: Claude Opus 5.5 <noreply@anthropic.com>
Claude-Session: https://claude.ai/code/session_01N6gjkuzRQ2MG332QwTLsQa
</commit_message>
<xml_diff>
--- a/presentation/Presentation_outil_maraichage.pptx
+++ b/presentation/Presentation_outil_maraichage.pptx
@@ -1070,7 +1070,7 @@
           <a:p>
             <a:r>
               <a:rPr lang="en-US" dirty="0"/>
-              <a:t>Accroche : un outil gratuit, sans compte, qui tient dans la poche du maraîcher. Présenter le contexte en une phrase : maraîchage bio, pépinière, adaptation au changement climatique.</a:t>
+              <a:t>Laisser cette diapo affichée en début de présentation pour que le public scanne le QR code. Accroche : un outil gratuit, sans compte, qui tient dans la poche du maraîcher. Présenter le contexte en une phrase : maraîchage bio, pépinière, adaptation au changement climatique.</a:t>
             </a:r>
             <a:endParaRPr lang="en-US" dirty="0"/>
           </a:p>
@@ -2464,16 +2464,40 @@
           </a:p>
         </p:txBody>
       </p:sp>
-      <p:sp>
-        <p:nvSpPr>
-          <p:cNvPr id="6" name="Text 3"/>
+      <p:pic>
+        <p:nvPicPr>
+          <p:cNvPr id="6" name="Image 1" descr="/tmp/claude-0/-home-user-meteo-rique-maraichage/b1532ef0-43df-5182-881a-fa5cd25c2188/scratchpad/qr.png">    </p:cNvPr>
+          <p:cNvPicPr>
+            <a:picLocks noChangeAspect="1"/>
+          </p:cNvPicPr>
+          <p:nvPr/>
+        </p:nvPicPr>
+        <p:blipFill>
+          <a:blip r:embed="rId2"/>
+          <a:stretch>
+            <a:fillRect/>
+          </a:stretch>
+        </p:blipFill>
+        <p:spPr>
+          <a:xfrm>
+            <a:off x="731520" y="4160520"/>
+            <a:ext cx="1371600" cy="1371600"/>
+          </a:xfrm>
+          <a:prstGeom prst="rect">
+            <a:avLst/>
+          </a:prstGeom>
+        </p:spPr>
+      </p:pic>
+      <p:sp>
+        <p:nvSpPr>
+          <p:cNvPr id="7" name="Text 3"/>
           <p:cNvSpPr txBox="1"/>
           <p:nvPr/>
         </p:nvSpPr>
         <p:spPr>
           <a:xfrm>
-            <a:off x="731520" y="5852160"/>
-            <a:ext cx="7315200" cy="365760"/>
+            <a:off x="2331720" y="4206240"/>
+            <a:ext cx="6035040" cy="1280160"/>
           </a:xfrm>
           <a:prstGeom prst="rect">
             <a:avLst/>
@@ -2486,17 +2510,99 @@
           <a:lstStyle/>
           <a:p>
             <a:pPr indent="0" marL="0">
-              <a:buNone/>
-            </a:pPr>
-            <a:r>
-              <a:rPr lang="en-US" sz="1200" dirty="0">
-                <a:solidFill>
-                  <a:srgbClr val="A8A48F"/>
+              <a:spcAft>
+                <a:spcPts val="400"/>
+              </a:spcAft>
+              <a:buNone/>
+            </a:pPr>
+            <a:r>
+              <a:rPr lang="en-US" sz="1700" b="1" dirty="0">
+                <a:solidFill>
+                  <a:srgbClr val="FFFFFF"/>
                 </a:solidFill>
                 <a:latin typeface="Calibri" pitchFamily="34" charset="0"/>
                 <a:ea typeface="Calibri" pitchFamily="34" charset="-122"/>
                 <a:cs typeface="Calibri" pitchFamily="34" charset="-120"/>
               </a:rPr>
+              <a:t>Installer l'application</a:t>
+            </a:r>
+            <a:endParaRPr lang="en-US" sz="1700" dirty="0"/>
+          </a:p>
+          <a:p>
+            <a:pPr indent="0" marL="0">
+              <a:spcAft>
+                <a:spcPts val="400"/>
+              </a:spcAft>
+              <a:buNone/>
+            </a:pPr>
+            <a:r>
+              <a:rPr lang="en-US" sz="1700" dirty="0">
+                <a:solidFill>
+                  <a:srgbClr val="D9C48E"/>
+                </a:solidFill>
+                <a:latin typeface="Calibri" pitchFamily="34" charset="0"/>
+                <a:ea typeface="Calibri" pitchFamily="34" charset="-122"/>
+                <a:cs typeface="Calibri" pitchFamily="34" charset="-120"/>
+              </a:rPr>
+              <a:t>elodie24000.github.io/meteo-risque-maraichage</a:t>
+            </a:r>
+            <a:endParaRPr lang="en-US" sz="1700" dirty="0"/>
+          </a:p>
+          <a:p>
+            <a:pPr indent="0" marL="0">
+              <a:spcAft>
+                <a:spcPts val="400"/>
+              </a:spcAft>
+              <a:buNone/>
+            </a:pPr>
+            <a:r>
+              <a:rPr lang="en-US" sz="1300" dirty="0">
+                <a:solidFill>
+                  <a:srgbClr val="A8A48F"/>
+                </a:solidFill>
+                <a:latin typeface="Calibri" pitchFamily="34" charset="0"/>
+                <a:ea typeface="Calibri" pitchFamily="34" charset="-122"/>
+                <a:cs typeface="Calibri" pitchFamily="34" charset="-120"/>
+              </a:rPr>
+              <a:t>Scannez le QR code, puis « Ajouter à l'écran d'accueil »</a:t>
+            </a:r>
+            <a:endParaRPr lang="en-US" sz="1700" dirty="0"/>
+          </a:p>
+        </p:txBody>
+      </p:sp>
+      <p:sp>
+        <p:nvSpPr>
+          <p:cNvPr id="8" name="Text 4"/>
+          <p:cNvSpPr txBox="1"/>
+          <p:nvPr/>
+        </p:nvSpPr>
+        <p:spPr>
+          <a:xfrm>
+            <a:off x="731520" y="5852160"/>
+            <a:ext cx="7315200" cy="365760"/>
+          </a:xfrm>
+          <a:prstGeom prst="rect">
+            <a:avLst/>
+          </a:prstGeom>
+          <a:noFill/>
+          <a:ln/>
+        </p:spPr>
+        <p:txBody>
+          <a:bodyPr wrap="square" lIns="0" tIns="0" rIns="0" bIns="0" rtlCol="0" anchor="ctr"/>
+          <a:lstStyle/>
+          <a:p>
+            <a:pPr indent="0" marL="0">
+              <a:buNone/>
+            </a:pPr>
+            <a:r>
+              <a:rPr lang="en-US" sz="1200" dirty="0">
+                <a:solidFill>
+                  <a:srgbClr val="A8A48F"/>
+                </a:solidFill>
+                <a:latin typeface="Calibri" pitchFamily="34" charset="0"/>
+                <a:ea typeface="Calibri" pitchFamily="34" charset="-122"/>
+                <a:cs typeface="Calibri" pitchFamily="34" charset="-120"/>
+              </a:rPr>
               <a:t>Élodie Plassin · Présentation du logiciel · Brouillon · septembre 2026</a:t>
             </a:r>
             <a:endParaRPr lang="en-US" sz="1200" dirty="0"/>
@@ -2505,7 +2611,7 @@
       </p:sp>
       <p:sp>
         <p:nvSpPr>
-          <p:cNvPr id="7" name="Shape 4"/>
+          <p:cNvPr id="9" name="Shape 5"/>
           <p:cNvSpPr/>
           <p:nvPr/>
         </p:nvSpPr>
@@ -2539,14 +2645,14 @@
       </p:sp>
       <p:pic>
         <p:nvPicPr>
-          <p:cNvPr id="8" name="Image 1" descr="/tmp/claude-0/-home-user-meteo-rique-maraichage/b1532ef0-43df-5182-881a-fa5cd25c2188/scratchpad/shot-especes.png">    </p:cNvPr>
+          <p:cNvPr id="10" name="Image 2" descr="/tmp/claude-0/-home-user-meteo-rique-maraichage/b1532ef0-43df-5182-881a-fa5cd25c2188/scratchpad/shot-especes.png">    </p:cNvPr>
           <p:cNvPicPr>
             <a:picLocks noChangeAspect="1"/>
           </p:cNvPicPr>
           <p:nvPr/>
         </p:nvPicPr>
         <p:blipFill>
-          <a:blip r:embed="rId2"/>
+          <a:blip r:embed="rId3"/>
           <a:stretch>
             <a:fillRect/>
           </a:stretch>

</xml_diff>

<commit_message>
revert: garder le nom meteo-rique-maraichage, fichiers de l'app identiques à main
Co-Authored-By: Claude Opus 5.5 <noreply@anthropic.com>
Claude-Session: https://claude.ai/code/session_01N6gjkuzRQ2MG332QwTLsQa
</commit_message>
<xml_diff>
--- a/presentation/Presentation_outil_maraichage.pptx
+++ b/presentation/Presentation_outil_maraichage.pptx
@@ -2544,7 +2544,7 @@
                 <a:ea typeface="Calibri" pitchFamily="34" charset="-122"/>
                 <a:cs typeface="Calibri" pitchFamily="34" charset="-120"/>
               </a:rPr>
-              <a:t>elodie24000.github.io/meteo-risque-maraichage</a:t>
+              <a:t>elodie24000.github.io/meteo-rique-maraichage</a:t>
             </a:r>
             <a:endParaRPr lang="en-US" sz="1700" dirty="0"/>
           </a:p>
@@ -3522,7 +3522,7 @@
                 <a:ea typeface="Calibri" pitchFamily="34" charset="-122"/>
                 <a:cs typeface="Calibri" pitchFamily="34" charset="-120"/>
               </a:rPr>
-              <a:t>elodie24000.github.io/meteo-risque-maraichage</a:t>
+              <a:t>elodie24000.github.io/meteo-rique-maraichage</a:t>
             </a:r>
             <a:endParaRPr lang="en-US" sz="1600" dirty="0"/>
           </a:p>

</xml_diff>

<commit_message>
docs(presentation): partenariats (diapo 10) et formulation PWA (diapo 8)
Co-Authored-By: Claude Opus 5.5 <noreply@anthropic.com>
Claude-Session: https://claude.ai/code/session_01N6gjkuzRQ2MG332QwTLsQa
</commit_message>
<xml_diff>
--- a/presentation/Presentation_outil_maraichage.pptx
+++ b/presentation/Presentation_outil_maraichage.pptx
@@ -3293,7 +3293,7 @@
                 <a:ea typeface="Calibri" pitchFamily="34" charset="-122"/>
                 <a:cs typeface="Calibri" pitchFamily="34" charset="-120"/>
               </a:rPr>
-              <a:t>À discuter : partenariats (GAB, lycées agricoles, collectivités), tests utilisateurs, validation agronomique.</a:t>
+              <a:t>Impératif : trouver des partenariats (GAB, MAB, fermes, espaces test) et mener des tests utilisateurs.</a:t>
             </a:r>
             <a:endParaRPr lang="en-US" sz="1500" dirty="0"/>
           </a:p>
@@ -8452,7 +8452,7 @@
                 <a:ea typeface="Calibri" pitchFamily="34" charset="-122"/>
                 <a:cs typeface="Calibri" pitchFamily="34" charset="-120"/>
               </a:rPr>
-              <a:t>Ajout à l'écran d'accueil, comme une application native.</a:t>
+              <a:t>Ajout à l'écran d'accueil, comme une application classique.</a:t>
             </a:r>
             <a:endParaRPr lang="en-US" sz="1400" dirty="0"/>
           </a:p>

</xml_diff>

<commit_message>
docs(presentation): sous-titre et QR code réduit (diapo 1), cartes centrées (diapo 2)
Co-Authored-By: Claude Opus 5.5 <noreply@anthropic.com>
Claude-Session: https://claude.ai/code/session_01N6gjkuzRQ2MG332QwTLsQa
</commit_message>
<xml_diff>
--- a/presentation/Presentation_outil_maraichage.pptx
+++ b/presentation/Presentation_outil_maraichage.pptx
@@ -2434,7 +2434,7 @@
         <p:spPr>
           <a:xfrm>
             <a:off x="731520" y="3017520"/>
-            <a:ext cx="6949440" cy="914400"/>
+            <a:ext cx="6949440" cy="822960"/>
           </a:xfrm>
           <a:prstGeom prst="rect">
             <a:avLst/>
@@ -2458,7 +2458,7 @@
                 <a:ea typeface="Calibri" pitchFamily="34" charset="-122"/>
                 <a:cs typeface="Calibri" pitchFamily="34" charset="-120"/>
               </a:rPr>
-              <a:t>Anticiper les maladies des cultures liées aux aléas climatiques — une application de poche pour le maraîchage biologique</a:t>
+              <a:t>Anticiper les maladies des cultures liées aux aléas climatiques — application téléphone</a:t>
             </a:r>
             <a:endParaRPr lang="en-US" sz="1800" dirty="0"/>
           </a:p>
@@ -2480,8 +2480,8 @@
         </p:blipFill>
         <p:spPr>
           <a:xfrm>
-            <a:off x="731520" y="4160520"/>
-            <a:ext cx="1371600" cy="1371600"/>
+            <a:off x="731520" y="4206240"/>
+            <a:ext cx="1051560" cy="1051560"/>
           </a:xfrm>
           <a:prstGeom prst="rect">
             <a:avLst/>
@@ -2496,8 +2496,8 @@
         </p:nvSpPr>
         <p:spPr>
           <a:xfrm>
-            <a:off x="2331720" y="4206240"/>
-            <a:ext cx="6035040" cy="1280160"/>
+            <a:off x="2011680" y="4206240"/>
+            <a:ext cx="6035040" cy="1051560"/>
           </a:xfrm>
           <a:prstGeom prst="rect">
             <a:avLst/>
@@ -2545,26 +2545,6 @@
                 <a:cs typeface="Calibri" pitchFamily="34" charset="-120"/>
               </a:rPr>
               <a:t>elodie24000.github.io/meteo-rique-maraichage</a:t>
-            </a:r>
-            <a:endParaRPr lang="en-US" sz="1700" dirty="0"/>
-          </a:p>
-          <a:p>
-            <a:pPr indent="0" marL="0">
-              <a:spcAft>
-                <a:spcPts val="400"/>
-              </a:spcAft>
-              <a:buNone/>
-            </a:pPr>
-            <a:r>
-              <a:rPr lang="en-US" sz="1300" dirty="0">
-                <a:solidFill>
-                  <a:srgbClr val="A8A48F"/>
-                </a:solidFill>
-                <a:latin typeface="Calibri" pitchFamily="34" charset="0"/>
-                <a:ea typeface="Calibri" pitchFamily="34" charset="-122"/>
-                <a:cs typeface="Calibri" pitchFamily="34" charset="-120"/>
-              </a:rPr>
-              <a:t>Scannez le QR code, puis « Ajouter à l'écran d'accueil »</a:t>
             </a:r>
             <a:endParaRPr lang="en-US" sz="1700" dirty="0"/>
           </a:p>
@@ -3713,7 +3693,7 @@
         </p:nvSpPr>
         <p:spPr>
           <a:xfrm>
-            <a:off x="960120" y="1965960"/>
+            <a:off x="1965960" y="1965960"/>
             <a:ext cx="777240" cy="777240"/>
           </a:xfrm>
           <a:prstGeom prst="ellipse">
@@ -3746,7 +3726,7 @@
         </p:blipFill>
         <p:spPr>
           <a:xfrm>
-            <a:off x="1154430" y="2160270"/>
+            <a:off x="2160270" y="2160270"/>
             <a:ext cx="388620" cy="388620"/>
           </a:xfrm>
           <a:prstGeom prst="rect">
@@ -3762,8 +3742,8 @@
         </p:nvSpPr>
         <p:spPr>
           <a:xfrm>
-            <a:off x="960120" y="2971800"/>
-            <a:ext cx="2834640" cy="731520"/>
+            <a:off x="914400" y="2971800"/>
+            <a:ext cx="2880360" cy="731520"/>
           </a:xfrm>
           <a:prstGeom prst="rect">
             <a:avLst/>
@@ -3772,10 +3752,10 @@
           <a:ln/>
         </p:spPr>
         <p:txBody>
-          <a:bodyPr wrap="square" lIns="0" tIns="0" rIns="0" bIns="0" rtlCol="0" anchor="ctr"/>
-          <a:lstStyle/>
-          <a:p>
-            <a:pPr indent="0" marL="0">
+          <a:bodyPr wrap="square" lIns="0" tIns="0" rIns="0" bIns="0" rtlCol="0" anchor="t"/>
+          <a:lstStyle/>
+          <a:p>
+            <a:pPr algn="ctr" indent="0" marL="0">
               <a:buNone/>
             </a:pPr>
             <a:r>
@@ -3801,8 +3781,8 @@
         </p:nvSpPr>
         <p:spPr>
           <a:xfrm>
-            <a:off x="960120" y="3749040"/>
-            <a:ext cx="2834640" cy="1645920"/>
+            <a:off x="914400" y="3794760"/>
+            <a:ext cx="2880360" cy="1645920"/>
           </a:xfrm>
           <a:prstGeom prst="rect">
             <a:avLst/>
@@ -3814,7 +3794,7 @@
           <a:bodyPr wrap="square" lIns="0" tIns="0" rIns="0" bIns="0" rtlCol="0" anchor="t"/>
           <a:lstStyle/>
           <a:p>
-            <a:pPr indent="0" marL="0">
+            <a:pPr algn="ctr" indent="0" marL="0">
               <a:buNone/>
             </a:pPr>
             <a:r>
@@ -3874,7 +3854,7 @@
         </p:nvSpPr>
         <p:spPr>
           <a:xfrm>
-            <a:off x="4663440" y="1965960"/>
+            <a:off x="5669280" y="1965960"/>
             <a:ext cx="777240" cy="777240"/>
           </a:xfrm>
           <a:prstGeom prst="ellipse">
@@ -3907,7 +3887,7 @@
         </p:blipFill>
         <p:spPr>
           <a:xfrm>
-            <a:off x="4857750" y="2160270"/>
+            <a:off x="5863590" y="2160270"/>
             <a:ext cx="388620" cy="388620"/>
           </a:xfrm>
           <a:prstGeom prst="rect">
@@ -3923,8 +3903,8 @@
         </p:nvSpPr>
         <p:spPr>
           <a:xfrm>
-            <a:off x="4663440" y="2971800"/>
-            <a:ext cx="2834640" cy="731520"/>
+            <a:off x="4617720" y="2971800"/>
+            <a:ext cx="2880360" cy="731520"/>
           </a:xfrm>
           <a:prstGeom prst="rect">
             <a:avLst/>
@@ -3933,10 +3913,10 @@
           <a:ln/>
         </p:spPr>
         <p:txBody>
-          <a:bodyPr wrap="square" lIns="0" tIns="0" rIns="0" bIns="0" rtlCol="0" anchor="ctr"/>
-          <a:lstStyle/>
-          <a:p>
-            <a:pPr indent="0" marL="0">
+          <a:bodyPr wrap="square" lIns="0" tIns="0" rIns="0" bIns="0" rtlCol="0" anchor="t"/>
+          <a:lstStyle/>
+          <a:p>
+            <a:pPr algn="ctr" indent="0" marL="0">
               <a:buNone/>
             </a:pPr>
             <a:r>
@@ -3962,8 +3942,8 @@
         </p:nvSpPr>
         <p:spPr>
           <a:xfrm>
-            <a:off x="4663440" y="3749040"/>
-            <a:ext cx="2834640" cy="1645920"/>
+            <a:off x="4617720" y="3794760"/>
+            <a:ext cx="2880360" cy="1645920"/>
           </a:xfrm>
           <a:prstGeom prst="rect">
             <a:avLst/>
@@ -3975,7 +3955,7 @@
           <a:bodyPr wrap="square" lIns="0" tIns="0" rIns="0" bIns="0" rtlCol="0" anchor="t"/>
           <a:lstStyle/>
           <a:p>
-            <a:pPr indent="0" marL="0">
+            <a:pPr algn="ctr" indent="0" marL="0">
               <a:buNone/>
             </a:pPr>
             <a:r>
@@ -4035,7 +4015,7 @@
         </p:nvSpPr>
         <p:spPr>
           <a:xfrm>
-            <a:off x="8366760" y="1965960"/>
+            <a:off x="9372600" y="1965960"/>
             <a:ext cx="777240" cy="777240"/>
           </a:xfrm>
           <a:prstGeom prst="ellipse">
@@ -4068,7 +4048,7 @@
         </p:blipFill>
         <p:spPr>
           <a:xfrm>
-            <a:off x="8561070" y="2160270"/>
+            <a:off x="9566910" y="2160270"/>
             <a:ext cx="388620" cy="388620"/>
           </a:xfrm>
           <a:prstGeom prst="rect">
@@ -4084,8 +4064,8 @@
         </p:nvSpPr>
         <p:spPr>
           <a:xfrm>
-            <a:off x="8366760" y="2971800"/>
-            <a:ext cx="2834640" cy="731520"/>
+            <a:off x="8321040" y="2971800"/>
+            <a:ext cx="2880360" cy="731520"/>
           </a:xfrm>
           <a:prstGeom prst="rect">
             <a:avLst/>
@@ -4094,10 +4074,10 @@
           <a:ln/>
         </p:spPr>
         <p:txBody>
-          <a:bodyPr wrap="square" lIns="0" tIns="0" rIns="0" bIns="0" rtlCol="0" anchor="ctr"/>
-          <a:lstStyle/>
-          <a:p>
-            <a:pPr indent="0" marL="0">
+          <a:bodyPr wrap="square" lIns="0" tIns="0" rIns="0" bIns="0" rtlCol="0" anchor="t"/>
+          <a:lstStyle/>
+          <a:p>
+            <a:pPr algn="ctr" indent="0" marL="0">
               <a:buNone/>
             </a:pPr>
             <a:r>
@@ -4123,8 +4103,8 @@
         </p:nvSpPr>
         <p:spPr>
           <a:xfrm>
-            <a:off x="8366760" y="3749040"/>
-            <a:ext cx="2834640" cy="1645920"/>
+            <a:off x="8321040" y="3794760"/>
+            <a:ext cx="2880360" cy="1645920"/>
           </a:xfrm>
           <a:prstGeom prst="rect">
             <a:avLst/>
@@ -4136,7 +4116,7 @@
           <a:bodyPr wrap="square" lIns="0" tIns="0" rIns="0" bIns="0" rtlCol="0" anchor="t"/>
           <a:lstStyle/>
           <a:p>
-            <a:pPr indent="0" marL="0">
+            <a:pPr algn="ctr" indent="0" marL="0">
               <a:buNone/>
             </a:pPr>
             <a:r>

</xml_diff>

<commit_message>
docs(presentation): icônes centrées verticalement (diapo 3)
Co-Authored-By: Claude Opus 5.5 <noreply@anthropic.com>
Claude-Session: https://claude.ai/code/session_01N6gjkuzRQ2MG332QwTLsQa
</commit_message>
<xml_diff>
--- a/presentation/Presentation_outil_maraichage.pptx
+++ b/presentation/Presentation_outil_maraichage.pptx
@@ -4300,7 +4300,7 @@
         </p:nvSpPr>
         <p:spPr>
           <a:xfrm>
-            <a:off x="914400" y="1920240"/>
+            <a:off x="914400" y="2217420"/>
             <a:ext cx="731520" cy="731520"/>
           </a:xfrm>
           <a:prstGeom prst="ellipse">
@@ -4333,7 +4333,7 @@
         </p:blipFill>
         <p:spPr>
           <a:xfrm>
-            <a:off x="1097280" y="2103120"/>
+            <a:off x="1097280" y="2400300"/>
             <a:ext cx="365760" cy="365760"/>
           </a:xfrm>
           <a:prstGeom prst="rect">
@@ -4461,7 +4461,7 @@
         </p:nvSpPr>
         <p:spPr>
           <a:xfrm>
-            <a:off x="4846320" y="1920240"/>
+            <a:off x="4846320" y="2217420"/>
             <a:ext cx="731520" cy="731520"/>
           </a:xfrm>
           <a:prstGeom prst="ellipse">
@@ -4494,7 +4494,7 @@
         </p:blipFill>
         <p:spPr>
           <a:xfrm>
-            <a:off x="5029200" y="2103120"/>
+            <a:off x="5029200" y="2400300"/>
             <a:ext cx="365760" cy="365760"/>
           </a:xfrm>
           <a:prstGeom prst="rect">
@@ -4622,7 +4622,7 @@
         </p:nvSpPr>
         <p:spPr>
           <a:xfrm>
-            <a:off x="914400" y="4160520"/>
+            <a:off x="914400" y="4457700"/>
             <a:ext cx="731520" cy="731520"/>
           </a:xfrm>
           <a:prstGeom prst="ellipse">
@@ -4655,7 +4655,7 @@
         </p:blipFill>
         <p:spPr>
           <a:xfrm>
-            <a:off x="1097280" y="4343400"/>
+            <a:off x="1097280" y="4640580"/>
             <a:ext cx="365760" cy="365760"/>
           </a:xfrm>
           <a:prstGeom prst="rect">
@@ -4783,7 +4783,7 @@
         </p:nvSpPr>
         <p:spPr>
           <a:xfrm>
-            <a:off x="4846320" y="4160520"/>
+            <a:off x="4846320" y="4457700"/>
             <a:ext cx="731520" cy="731520"/>
           </a:xfrm>
           <a:prstGeom prst="ellipse">
@@ -4816,7 +4816,7 @@
         </p:blipFill>
         <p:spPr>
           <a:xfrm>
-            <a:off x="5029200" y="4343400"/>
+            <a:off x="5029200" y="4640580"/>
             <a:ext cx="365760" cy="365760"/>
           </a:xfrm>
           <a:prstGeom prst="rect">

</xml_diff>

<commit_message>
docs(presentation): « indice de risque » au lieu de « score » (diapos 3, 4, 5)
Co-Authored-By: Claude Opus 5.5 <noreply@anthropic.com>
Claude-Session: https://claude.ai/code/session_01N6gjkuzRQ2MG332QwTLsQa
</commit_message>
<xml_diff>
--- a/presentation/Presentation_outil_maraichage.pptx
+++ b/presentation/Presentation_outil_maraichage.pptx
@@ -143,7 +143,7 @@
                 </a:solidFill>
                 <a:latin typeface="Calibri"/>
               </a:rPr>
-              <a:t>Contribution maximale au score (points)</a:t>
+              <a:t>Poids maximal de chaque facteur dans l'indice (sur 100)</a:t>
             </a:r>
           </a:p>
         </c:rich>
@@ -1598,7 +1598,7 @@
           <a:p>
             <a:r>
               <a:rPr lang="en-US" dirty="0"/>
-              <a:t>Point fort pour un public scientifique : l'algorithme est déterministe, lisible, et chaque score est justifié. Seuils volontairement prudents.</a:t>
+              <a:t>Point fort pour un public scientifique : l'algorithme est déterministe, lisible, et chaque indice est justifié. Seuils volontairement prudents.</a:t>
             </a:r>
             <a:endParaRPr lang="en-US" dirty="0"/>
           </a:p>
@@ -4574,7 +4574,7 @@
                 <a:ea typeface="Calibri" pitchFamily="34" charset="-122"/>
                 <a:cs typeface="Calibri" pitchFamily="34" charset="-120"/>
               </a:rPr>
-              <a:t>Score de risque jour par jour pour 40 maladies, croisé avec les cultures.</a:t>
+              <a:t>Indice de risque jour par jour pour 40 maladies, croisé avec les cultures.</a:t>
             </a:r>
             <a:endParaRPr lang="en-US" sz="1400" dirty="0"/>
           </a:p>
@@ -5731,7 +5731,7 @@
                 <a:ea typeface="Cambria" pitchFamily="34" charset="-122"/>
                 <a:cs typeface="Cambria" pitchFamily="34" charset="-120"/>
               </a:rPr>
-              <a:t>5. Score 0–100</a:t>
+              <a:t>5. Indice de risque</a:t>
             </a:r>
             <a:endParaRPr lang="en-US" sz="1500" dirty="0"/>
           </a:p>
@@ -5928,7 +5928,7 @@
                 <a:ea typeface="Cambria" pitchFamily="34" charset="-122"/>
                 <a:cs typeface="Cambria" pitchFamily="34" charset="-120"/>
               </a:rPr>
-              <a:t>Un score </a:t>
+              <a:t>Un indice de risque, </a:t>
             </a:r>
             <a:pPr indent="0" marL="0">
               <a:buNone/>
@@ -5942,7 +5942,7 @@
                 <a:ea typeface="Cambria" pitchFamily="34" charset="-122"/>
                 <a:cs typeface="Cambria" pitchFamily="34" charset="-120"/>
               </a:rPr>
-              <a:t>transparent et explicable</a:t>
+              <a:t>jour par jour</a:t>
             </a:r>
             <a:endParaRPr lang="en-US" sz="3600" dirty="0"/>
           </a:p>

</xml_diff>

<commit_message>
docs(presentation): QR code d'installation sur la diapo de conclusion
Co-Authored-By: Claude Opus 5.5 <noreply@anthropic.com>
Claude-Session: https://claude.ai/code/session_01N6gjkuzRQ2MG332QwTLsQa
</commit_message>
<xml_diff>
--- a/presentation/Presentation_outil_maraichage.pptx
+++ b/presentation/Presentation_outil_maraichage.pptx
@@ -1246,7 +1246,7 @@
           <a:p>
             <a:r>
               <a:rPr lang="en-US" dirty="0"/>
-              <a:t>Questions / démonstration en direct. Préparer un QR code vers l'application.</a:t>
+              <a:t>Questions / démonstration en direct. Le QR code renvoie vers l'application.</a:t>
             </a:r>
             <a:endParaRPr lang="en-US" dirty="0"/>
           </a:p>
@@ -3452,16 +3452,40 @@
           </a:p>
         </p:txBody>
       </p:sp>
-      <p:sp>
-        <p:nvSpPr>
-          <p:cNvPr id="6" name="Text 3"/>
+      <p:pic>
+        <p:nvPicPr>
+          <p:cNvPr id="6" name="Image 1" descr="/tmp/claude-0/-home-user-meteo-rique-maraichage/b1532ef0-43df-5182-881a-fa5cd25c2188/scratchpad/qr.png">    </p:cNvPr>
+          <p:cNvPicPr>
+            <a:picLocks noChangeAspect="1"/>
+          </p:cNvPicPr>
+          <p:nvPr/>
+        </p:nvPicPr>
+        <p:blipFill>
+          <a:blip r:embed="rId2"/>
+          <a:stretch>
+            <a:fillRect/>
+          </a:stretch>
+        </p:blipFill>
+        <p:spPr>
+          <a:xfrm>
+            <a:off x="731520" y="4434840"/>
+            <a:ext cx="1051560" cy="1051560"/>
+          </a:xfrm>
+          <a:prstGeom prst="rect">
+            <a:avLst/>
+          </a:prstGeom>
+        </p:spPr>
+      </p:pic>
+      <p:sp>
+        <p:nvSpPr>
+          <p:cNvPr id="7" name="Text 3"/>
           <p:cNvSpPr txBox="1"/>
           <p:nvPr/>
         </p:nvSpPr>
         <p:spPr>
           <a:xfrm>
-            <a:off x="731520" y="4754880"/>
-            <a:ext cx="6949440" cy="822960"/>
+            <a:off x="2011680" y="4434840"/>
+            <a:ext cx="6035040" cy="1051560"/>
           </a:xfrm>
           <a:prstGeom prst="rect">
             <a:avLst/>
@@ -3474,10 +3498,13 @@
           <a:lstStyle/>
           <a:p>
             <a:pPr indent="0" marL="0">
-              <a:buNone/>
-            </a:pPr>
-            <a:r>
-              <a:rPr lang="en-US" sz="1600" b="1" dirty="0">
+              <a:spcAft>
+                <a:spcPts val="400"/>
+              </a:spcAft>
+              <a:buNone/>
+            </a:pPr>
+            <a:r>
+              <a:rPr lang="en-US" sz="1700" b="1" dirty="0">
                 <a:solidFill>
                   <a:srgbClr val="FFFFFF"/>
                 </a:solidFill>
@@ -3485,16 +3512,19 @@
                 <a:ea typeface="Calibri" pitchFamily="34" charset="-122"/>
                 <a:cs typeface="Calibri" pitchFamily="34" charset="-120"/>
               </a:rPr>
-              <a:t>Essayer l'application</a:t>
-            </a:r>
-            <a:endParaRPr lang="en-US" sz="1600" dirty="0"/>
+              <a:t>Installer l'application</a:t>
+            </a:r>
+            <a:endParaRPr lang="en-US" sz="1700" dirty="0"/>
           </a:p>
           <a:p>
             <a:pPr indent="0" marL="0">
-              <a:buNone/>
-            </a:pPr>
-            <a:r>
-              <a:rPr lang="en-US" sz="1600" dirty="0">
+              <a:spcAft>
+                <a:spcPts val="400"/>
+              </a:spcAft>
+              <a:buNone/>
+            </a:pPr>
+            <a:r>
+              <a:rPr lang="en-US" sz="1700" dirty="0">
                 <a:solidFill>
                   <a:srgbClr val="D9C48E"/>
                 </a:solidFill>
@@ -3504,13 +3534,13 @@
               </a:rPr>
               <a:t>elodie24000.github.io/meteo-rique-maraichage</a:t>
             </a:r>
-            <a:endParaRPr lang="en-US" sz="1600" dirty="0"/>
-          </a:p>
-        </p:txBody>
-      </p:sp>
-      <p:sp>
-        <p:nvSpPr>
-          <p:cNvPr id="7" name="Shape 4"/>
+            <a:endParaRPr lang="en-US" sz="1700" dirty="0"/>
+          </a:p>
+        </p:txBody>
+      </p:sp>
+      <p:sp>
+        <p:nvSpPr>
+          <p:cNvPr id="8" name="Shape 4"/>
           <p:cNvSpPr/>
           <p:nvPr/>
         </p:nvSpPr>
@@ -3544,14 +3574,14 @@
       </p:sp>
       <p:pic>
         <p:nvPicPr>
-          <p:cNvPr id="8" name="Image 1" descr="/tmp/claude-0/-home-user-meteo-rique-maraichage/b1532ef0-43df-5182-881a-fa5cd25c2188/scratchpad/shot-calc-fert.png">    </p:cNvPr>
+          <p:cNvPr id="9" name="Image 2" descr="/tmp/claude-0/-home-user-meteo-rique-maraichage/b1532ef0-43df-5182-881a-fa5cd25c2188/scratchpad/shot-calc-fert.png">    </p:cNvPr>
           <p:cNvPicPr>
             <a:picLocks noChangeAspect="1"/>
           </p:cNvPicPr>
           <p:nvPr/>
         </p:nvPicPr>
         <p:blipFill>
-          <a:blip r:embed="rId2"/>
+          <a:blip r:embed="rId3"/>
           <a:stretch>
             <a:fillRect/>
           </a:stretch>

</xml_diff>